<commit_message>
Polish the lab chrome, study rooms, downloads, and guide.
Replace the utility strip and jump menu with a top-left sliding drawer, one banner row, and a phone bar. Box the disclaimer, limit identity links to the lab set, and expand diagrams, flows, games, and standalone downloads. The guide is a compact CSS monkey with choice cards and optional browser speech.

Co-authored-by: CYPHER0X9 <cipher0x9@users.noreply.github.com>
</commit_message>
<xml_diff>
--- a/downloads/ba-study-deck.pptx
+++ b/downloads/ba-study-deck.pptx
@@ -3203,7 +3203,7 @@
           </a:p>
           <a:p>
             <a:r>
-              <a:t>Independent, free, learning-only student project. Respects every company, tradition, and vendor. Trademarks and sources belong to their owners. Not sold. Concerns are handled by correcting or removing content promptly vi</a:t>
+              <a:t>Independent, free, learning-only student project. Respects every company and vendor. Trademarks belong to their owners. Not affiliated or endorsed. Concerns are removed or corrected promptly via the contact form at https</a:t>
             </a:r>
           </a:p>
         </p:txBody>
@@ -3236,7 +3236,7 @@
               <a:defRPr sz="1200"/>
             </a:pPr>
             <a:r>
-              <a:t>GitHub</a:t>
+              <a:t>Website</a:t>
             </a:r>
           </a:p>
         </p:txBody>
@@ -3269,7 +3269,7 @@
               <a:defRPr sz="1200"/>
             </a:pPr>
             <a:r>
-              <a:t>Website</a:t>
+              <a:t>GitHub</a:t>
             </a:r>
           </a:p>
         </p:txBody>
@@ -3302,7 +3302,7 @@
               <a:defRPr sz="1200"/>
             </a:pPr>
             <a:r>
-              <a:t>X</a:t>
+              <a:t>Profile</a:t>
             </a:r>
           </a:p>
         </p:txBody>
@@ -3335,7 +3335,7 @@
               <a:defRPr sz="1200"/>
             </a:pPr>
             <a:r>
-              <a:t>LinkedIn</a:t>
+              <a:t>X</a:t>
             </a:r>
           </a:p>
         </p:txBody>
@@ -3368,7 +3368,73 @@
               <a:defRPr sz="1200"/>
             </a:pPr>
             <a:r>
+              <a:t>LinkedIn</a:t>
+            </a:r>
+          </a:p>
+        </p:txBody>
+      </p:sp>
+      <p:sp>
+        <p:nvSpPr>
+          <p:cNvPr id="10" name="TextBox 9">
+            <a:hlinkClick r:id="rId7"/>
+          </p:cNvPr>
+          <p:cNvSpPr txBox="1"/>
+          <p:nvPr/>
+        </p:nvSpPr>
+        <p:spPr>
+          <a:xfrm>
+            <a:off x="10972800" y="6355080"/>
+            <a:ext cx="2011680" cy="320040"/>
+          </a:xfrm>
+          <a:prstGeom prst="rect">
+            <a:avLst/>
+          </a:prstGeom>
+          <a:noFill/>
+        </p:spPr>
+        <p:txBody>
+          <a:bodyPr wrap="none">
+            <a:spAutoFit/>
+          </a:bodyPr>
+          <a:lstStyle/>
+          <a:p>
+            <a:pPr>
+              <a:defRPr sz="1200"/>
+            </a:pPr>
+            <a:r>
               <a:t>Hugging Face</a:t>
+            </a:r>
+          </a:p>
+        </p:txBody>
+      </p:sp>
+      <p:sp>
+        <p:nvSpPr>
+          <p:cNvPr id="11" name="TextBox 10">
+            <a:hlinkClick r:id="rId8"/>
+          </p:cNvPr>
+          <p:cNvSpPr txBox="1"/>
+          <p:nvPr/>
+        </p:nvSpPr>
+        <p:spPr>
+          <a:xfrm>
+            <a:off x="13075920" y="6355080"/>
+            <a:ext cx="2011680" cy="320040"/>
+          </a:xfrm>
+          <a:prstGeom prst="rect">
+            <a:avLst/>
+          </a:prstGeom>
+          <a:noFill/>
+        </p:spPr>
+        <p:txBody>
+          <a:bodyPr wrap="none">
+            <a:spAutoFit/>
+          </a:bodyPr>
+          <a:lstStyle/>
+          <a:p>
+            <a:pPr>
+              <a:defRPr sz="1200"/>
+            </a:pPr>
+            <a:r>
+              <a:t>Contact</a:t>
             </a:r>
           </a:p>
         </p:txBody>
@@ -3500,7 +3566,7 @@
           </a:p>
           <a:p>
             <a:r>
-              <a:t>Independent, free, learning-only student project. Respects every company, tradition, and vendor. Trademarks and sources belong to their owners. Not sold. Concerns are handled by correcting or removing content promptly vi</a:t>
+              <a:t>Independent, free, learning-only student project. Respects every company and vendor. Trademarks belong to their owners. Not affiliated or endorsed. Concerns are removed or corrected promptly via the contact form at https</a:t>
             </a:r>
           </a:p>
         </p:txBody>
@@ -3533,7 +3599,7 @@
               <a:defRPr sz="1200"/>
             </a:pPr>
             <a:r>
-              <a:t>GitHub</a:t>
+              <a:t>Website</a:t>
             </a:r>
           </a:p>
         </p:txBody>
@@ -3566,7 +3632,7 @@
               <a:defRPr sz="1200"/>
             </a:pPr>
             <a:r>
-              <a:t>Website</a:t>
+              <a:t>GitHub</a:t>
             </a:r>
           </a:p>
         </p:txBody>
@@ -3599,7 +3665,7 @@
               <a:defRPr sz="1200"/>
             </a:pPr>
             <a:r>
-              <a:t>X</a:t>
+              <a:t>Profile</a:t>
             </a:r>
           </a:p>
         </p:txBody>
@@ -3632,7 +3698,7 @@
               <a:defRPr sz="1200"/>
             </a:pPr>
             <a:r>
-              <a:t>LinkedIn</a:t>
+              <a:t>X</a:t>
             </a:r>
           </a:p>
         </p:txBody>
@@ -3665,7 +3731,73 @@
               <a:defRPr sz="1200"/>
             </a:pPr>
             <a:r>
+              <a:t>LinkedIn</a:t>
+            </a:r>
+          </a:p>
+        </p:txBody>
+      </p:sp>
+      <p:sp>
+        <p:nvSpPr>
+          <p:cNvPr id="10" name="TextBox 9">
+            <a:hlinkClick r:id="rId7"/>
+          </p:cNvPr>
+          <p:cNvSpPr txBox="1"/>
+          <p:nvPr/>
+        </p:nvSpPr>
+        <p:spPr>
+          <a:xfrm>
+            <a:off x="10972800" y="6355080"/>
+            <a:ext cx="2011680" cy="320040"/>
+          </a:xfrm>
+          <a:prstGeom prst="rect">
+            <a:avLst/>
+          </a:prstGeom>
+          <a:noFill/>
+        </p:spPr>
+        <p:txBody>
+          <a:bodyPr wrap="none">
+            <a:spAutoFit/>
+          </a:bodyPr>
+          <a:lstStyle/>
+          <a:p>
+            <a:pPr>
+              <a:defRPr sz="1200"/>
+            </a:pPr>
+            <a:r>
               <a:t>Hugging Face</a:t>
+            </a:r>
+          </a:p>
+        </p:txBody>
+      </p:sp>
+      <p:sp>
+        <p:nvSpPr>
+          <p:cNvPr id="11" name="TextBox 10">
+            <a:hlinkClick r:id="rId8"/>
+          </p:cNvPr>
+          <p:cNvSpPr txBox="1"/>
+          <p:nvPr/>
+        </p:nvSpPr>
+        <p:spPr>
+          <a:xfrm>
+            <a:off x="13075920" y="6355080"/>
+            <a:ext cx="2011680" cy="320040"/>
+          </a:xfrm>
+          <a:prstGeom prst="rect">
+            <a:avLst/>
+          </a:prstGeom>
+          <a:noFill/>
+        </p:spPr>
+        <p:txBody>
+          <a:bodyPr wrap="none">
+            <a:spAutoFit/>
+          </a:bodyPr>
+          <a:lstStyle/>
+          <a:p>
+            <a:pPr>
+              <a:defRPr sz="1200"/>
+            </a:pPr>
+            <a:r>
+              <a:t>Contact</a:t>
             </a:r>
           </a:p>
         </p:txBody>
@@ -3805,7 +3937,7 @@
           </a:p>
           <a:p>
             <a:r>
-              <a:t>Independent, free, learning-only student project. Respects every company, tradition, and vendor. Trademarks and sources belong to their owners. Not sold. Concerns are handled by correcting or removing content promptly vi</a:t>
+              <a:t>Independent, free, learning-only student project. Respects every company and vendor. Trademarks belong to their owners. Not affiliated or endorsed. Concerns are removed or corrected promptly via the contact form at https</a:t>
             </a:r>
           </a:p>
         </p:txBody>
@@ -3838,7 +3970,7 @@
               <a:defRPr sz="1200"/>
             </a:pPr>
             <a:r>
-              <a:t>GitHub</a:t>
+              <a:t>Website</a:t>
             </a:r>
           </a:p>
         </p:txBody>
@@ -3871,7 +4003,7 @@
               <a:defRPr sz="1200"/>
             </a:pPr>
             <a:r>
-              <a:t>Website</a:t>
+              <a:t>GitHub</a:t>
             </a:r>
           </a:p>
         </p:txBody>
@@ -3904,7 +4036,7 @@
               <a:defRPr sz="1200"/>
             </a:pPr>
             <a:r>
-              <a:t>X</a:t>
+              <a:t>Profile</a:t>
             </a:r>
           </a:p>
         </p:txBody>
@@ -3937,7 +4069,7 @@
               <a:defRPr sz="1200"/>
             </a:pPr>
             <a:r>
-              <a:t>LinkedIn</a:t>
+              <a:t>X</a:t>
             </a:r>
           </a:p>
         </p:txBody>
@@ -3970,7 +4102,73 @@
               <a:defRPr sz="1200"/>
             </a:pPr>
             <a:r>
+              <a:t>LinkedIn</a:t>
+            </a:r>
+          </a:p>
+        </p:txBody>
+      </p:sp>
+      <p:sp>
+        <p:nvSpPr>
+          <p:cNvPr id="10" name="TextBox 9">
+            <a:hlinkClick r:id="rId7"/>
+          </p:cNvPr>
+          <p:cNvSpPr txBox="1"/>
+          <p:nvPr/>
+        </p:nvSpPr>
+        <p:spPr>
+          <a:xfrm>
+            <a:off x="10972800" y="6355080"/>
+            <a:ext cx="2011680" cy="320040"/>
+          </a:xfrm>
+          <a:prstGeom prst="rect">
+            <a:avLst/>
+          </a:prstGeom>
+          <a:noFill/>
+        </p:spPr>
+        <p:txBody>
+          <a:bodyPr wrap="none">
+            <a:spAutoFit/>
+          </a:bodyPr>
+          <a:lstStyle/>
+          <a:p>
+            <a:pPr>
+              <a:defRPr sz="1200"/>
+            </a:pPr>
+            <a:r>
               <a:t>Hugging Face</a:t>
+            </a:r>
+          </a:p>
+        </p:txBody>
+      </p:sp>
+      <p:sp>
+        <p:nvSpPr>
+          <p:cNvPr id="11" name="TextBox 10">
+            <a:hlinkClick r:id="rId8"/>
+          </p:cNvPr>
+          <p:cNvSpPr txBox="1"/>
+          <p:nvPr/>
+        </p:nvSpPr>
+        <p:spPr>
+          <a:xfrm>
+            <a:off x="13075920" y="6355080"/>
+            <a:ext cx="2011680" cy="320040"/>
+          </a:xfrm>
+          <a:prstGeom prst="rect">
+            <a:avLst/>
+          </a:prstGeom>
+          <a:noFill/>
+        </p:spPr>
+        <p:txBody>
+          <a:bodyPr wrap="none">
+            <a:spAutoFit/>
+          </a:bodyPr>
+          <a:lstStyle/>
+          <a:p>
+            <a:pPr>
+              <a:defRPr sz="1200"/>
+            </a:pPr>
+            <a:r>
+              <a:t>Contact</a:t>
             </a:r>
           </a:p>
         </p:txBody>
@@ -4102,7 +4300,7 @@
           </a:p>
           <a:p>
             <a:r>
-              <a:t>Independent, free, learning-only student project. Respects every company, tradition, and vendor. Trademarks and sources belong to their owners. Not sold. Concerns are handled by correcting or removing content promptly vi</a:t>
+              <a:t>Independent, free, learning-only student project. Respects every company and vendor. Trademarks belong to their owners. Not affiliated or endorsed. Concerns are removed or corrected promptly via the contact form at https</a:t>
             </a:r>
           </a:p>
         </p:txBody>
@@ -4135,7 +4333,7 @@
               <a:defRPr sz="1200"/>
             </a:pPr>
             <a:r>
-              <a:t>GitHub</a:t>
+              <a:t>Website</a:t>
             </a:r>
           </a:p>
         </p:txBody>
@@ -4168,7 +4366,7 @@
               <a:defRPr sz="1200"/>
             </a:pPr>
             <a:r>
-              <a:t>Website</a:t>
+              <a:t>GitHub</a:t>
             </a:r>
           </a:p>
         </p:txBody>
@@ -4201,7 +4399,7 @@
               <a:defRPr sz="1200"/>
             </a:pPr>
             <a:r>
-              <a:t>X</a:t>
+              <a:t>Profile</a:t>
             </a:r>
           </a:p>
         </p:txBody>
@@ -4234,7 +4432,7 @@
               <a:defRPr sz="1200"/>
             </a:pPr>
             <a:r>
-              <a:t>LinkedIn</a:t>
+              <a:t>X</a:t>
             </a:r>
           </a:p>
         </p:txBody>
@@ -4267,7 +4465,73 @@
               <a:defRPr sz="1200"/>
             </a:pPr>
             <a:r>
+              <a:t>LinkedIn</a:t>
+            </a:r>
+          </a:p>
+        </p:txBody>
+      </p:sp>
+      <p:sp>
+        <p:nvSpPr>
+          <p:cNvPr id="10" name="TextBox 9">
+            <a:hlinkClick r:id="rId7"/>
+          </p:cNvPr>
+          <p:cNvSpPr txBox="1"/>
+          <p:nvPr/>
+        </p:nvSpPr>
+        <p:spPr>
+          <a:xfrm>
+            <a:off x="10972800" y="6355080"/>
+            <a:ext cx="2011680" cy="320040"/>
+          </a:xfrm>
+          <a:prstGeom prst="rect">
+            <a:avLst/>
+          </a:prstGeom>
+          <a:noFill/>
+        </p:spPr>
+        <p:txBody>
+          <a:bodyPr wrap="none">
+            <a:spAutoFit/>
+          </a:bodyPr>
+          <a:lstStyle/>
+          <a:p>
+            <a:pPr>
+              <a:defRPr sz="1200"/>
+            </a:pPr>
+            <a:r>
               <a:t>Hugging Face</a:t>
+            </a:r>
+          </a:p>
+        </p:txBody>
+      </p:sp>
+      <p:sp>
+        <p:nvSpPr>
+          <p:cNvPr id="11" name="TextBox 10">
+            <a:hlinkClick r:id="rId8"/>
+          </p:cNvPr>
+          <p:cNvSpPr txBox="1"/>
+          <p:nvPr/>
+        </p:nvSpPr>
+        <p:spPr>
+          <a:xfrm>
+            <a:off x="13075920" y="6355080"/>
+            <a:ext cx="2011680" cy="320040"/>
+          </a:xfrm>
+          <a:prstGeom prst="rect">
+            <a:avLst/>
+          </a:prstGeom>
+          <a:noFill/>
+        </p:spPr>
+        <p:txBody>
+          <a:bodyPr wrap="none">
+            <a:spAutoFit/>
+          </a:bodyPr>
+          <a:lstStyle/>
+          <a:p>
+            <a:pPr>
+              <a:defRPr sz="1200"/>
+            </a:pPr>
+            <a:r>
+              <a:t>Contact</a:t>
             </a:r>
           </a:p>
         </p:txBody>
@@ -4399,7 +4663,7 @@
           </a:p>
           <a:p>
             <a:r>
-              <a:t>Independent, free, learning-only student project. Respects every company, tradition, and vendor. Trademarks and sources belong to their owners. Not sold. Concerns are handled by correcting or removing content promptly vi</a:t>
+              <a:t>Independent, free, learning-only student project. Respects every company and vendor. Trademarks belong to their owners. Not affiliated or endorsed. Concerns are removed or corrected promptly via the contact form at https</a:t>
             </a:r>
           </a:p>
         </p:txBody>
@@ -4432,7 +4696,7 @@
               <a:defRPr sz="1200"/>
             </a:pPr>
             <a:r>
-              <a:t>GitHub</a:t>
+              <a:t>Website</a:t>
             </a:r>
           </a:p>
         </p:txBody>
@@ -4465,7 +4729,7 @@
               <a:defRPr sz="1200"/>
             </a:pPr>
             <a:r>
-              <a:t>Website</a:t>
+              <a:t>GitHub</a:t>
             </a:r>
           </a:p>
         </p:txBody>
@@ -4498,7 +4762,7 @@
               <a:defRPr sz="1200"/>
             </a:pPr>
             <a:r>
-              <a:t>X</a:t>
+              <a:t>Profile</a:t>
             </a:r>
           </a:p>
         </p:txBody>
@@ -4531,7 +4795,7 @@
               <a:defRPr sz="1200"/>
             </a:pPr>
             <a:r>
-              <a:t>LinkedIn</a:t>
+              <a:t>X</a:t>
             </a:r>
           </a:p>
         </p:txBody>
@@ -4564,7 +4828,73 @@
               <a:defRPr sz="1200"/>
             </a:pPr>
             <a:r>
+              <a:t>LinkedIn</a:t>
+            </a:r>
+          </a:p>
+        </p:txBody>
+      </p:sp>
+      <p:sp>
+        <p:nvSpPr>
+          <p:cNvPr id="10" name="TextBox 9">
+            <a:hlinkClick r:id="rId7"/>
+          </p:cNvPr>
+          <p:cNvSpPr txBox="1"/>
+          <p:nvPr/>
+        </p:nvSpPr>
+        <p:spPr>
+          <a:xfrm>
+            <a:off x="10972800" y="6355080"/>
+            <a:ext cx="2011680" cy="320040"/>
+          </a:xfrm>
+          <a:prstGeom prst="rect">
+            <a:avLst/>
+          </a:prstGeom>
+          <a:noFill/>
+        </p:spPr>
+        <p:txBody>
+          <a:bodyPr wrap="none">
+            <a:spAutoFit/>
+          </a:bodyPr>
+          <a:lstStyle/>
+          <a:p>
+            <a:pPr>
+              <a:defRPr sz="1200"/>
+            </a:pPr>
+            <a:r>
               <a:t>Hugging Face</a:t>
+            </a:r>
+          </a:p>
+        </p:txBody>
+      </p:sp>
+      <p:sp>
+        <p:nvSpPr>
+          <p:cNvPr id="11" name="TextBox 10">
+            <a:hlinkClick r:id="rId8"/>
+          </p:cNvPr>
+          <p:cNvSpPr txBox="1"/>
+          <p:nvPr/>
+        </p:nvSpPr>
+        <p:spPr>
+          <a:xfrm>
+            <a:off x="13075920" y="6355080"/>
+            <a:ext cx="2011680" cy="320040"/>
+          </a:xfrm>
+          <a:prstGeom prst="rect">
+            <a:avLst/>
+          </a:prstGeom>
+          <a:noFill/>
+        </p:spPr>
+        <p:txBody>
+          <a:bodyPr wrap="none">
+            <a:spAutoFit/>
+          </a:bodyPr>
+          <a:lstStyle/>
+          <a:p>
+            <a:pPr>
+              <a:defRPr sz="1200"/>
+            </a:pPr>
+            <a:r>
+              <a:t>Contact</a:t>
             </a:r>
           </a:p>
         </p:txBody>
@@ -4696,7 +5026,7 @@
           </a:p>
           <a:p>
             <a:r>
-              <a:t>Independent, free, learning-only student project. Respects every company, tradition, and vendor. Trademarks and sources belong to their owners. Not sold. Concerns are handled by correcting or removing content promptly vi</a:t>
+              <a:t>Independent, free, learning-only student project. Respects every company and vendor. Trademarks belong to their owners. Not affiliated or endorsed. Concerns are removed or corrected promptly via the contact form at https</a:t>
             </a:r>
           </a:p>
         </p:txBody>
@@ -4729,7 +5059,7 @@
               <a:defRPr sz="1200"/>
             </a:pPr>
             <a:r>
-              <a:t>GitHub</a:t>
+              <a:t>Website</a:t>
             </a:r>
           </a:p>
         </p:txBody>
@@ -4762,7 +5092,7 @@
               <a:defRPr sz="1200"/>
             </a:pPr>
             <a:r>
-              <a:t>Website</a:t>
+              <a:t>GitHub</a:t>
             </a:r>
           </a:p>
         </p:txBody>
@@ -4795,7 +5125,7 @@
               <a:defRPr sz="1200"/>
             </a:pPr>
             <a:r>
-              <a:t>X</a:t>
+              <a:t>Profile</a:t>
             </a:r>
           </a:p>
         </p:txBody>
@@ -4828,7 +5158,7 @@
               <a:defRPr sz="1200"/>
             </a:pPr>
             <a:r>
-              <a:t>LinkedIn</a:t>
+              <a:t>X</a:t>
             </a:r>
           </a:p>
         </p:txBody>
@@ -4861,7 +5191,73 @@
               <a:defRPr sz="1200"/>
             </a:pPr>
             <a:r>
+              <a:t>LinkedIn</a:t>
+            </a:r>
+          </a:p>
+        </p:txBody>
+      </p:sp>
+      <p:sp>
+        <p:nvSpPr>
+          <p:cNvPr id="10" name="TextBox 9">
+            <a:hlinkClick r:id="rId7"/>
+          </p:cNvPr>
+          <p:cNvSpPr txBox="1"/>
+          <p:nvPr/>
+        </p:nvSpPr>
+        <p:spPr>
+          <a:xfrm>
+            <a:off x="10972800" y="6355080"/>
+            <a:ext cx="2011680" cy="320040"/>
+          </a:xfrm>
+          <a:prstGeom prst="rect">
+            <a:avLst/>
+          </a:prstGeom>
+          <a:noFill/>
+        </p:spPr>
+        <p:txBody>
+          <a:bodyPr wrap="none">
+            <a:spAutoFit/>
+          </a:bodyPr>
+          <a:lstStyle/>
+          <a:p>
+            <a:pPr>
+              <a:defRPr sz="1200"/>
+            </a:pPr>
+            <a:r>
               <a:t>Hugging Face</a:t>
+            </a:r>
+          </a:p>
+        </p:txBody>
+      </p:sp>
+      <p:sp>
+        <p:nvSpPr>
+          <p:cNvPr id="11" name="TextBox 10">
+            <a:hlinkClick r:id="rId8"/>
+          </p:cNvPr>
+          <p:cNvSpPr txBox="1"/>
+          <p:nvPr/>
+        </p:nvSpPr>
+        <p:spPr>
+          <a:xfrm>
+            <a:off x="13075920" y="6355080"/>
+            <a:ext cx="2011680" cy="320040"/>
+          </a:xfrm>
+          <a:prstGeom prst="rect">
+            <a:avLst/>
+          </a:prstGeom>
+          <a:noFill/>
+        </p:spPr>
+        <p:txBody>
+          <a:bodyPr wrap="none">
+            <a:spAutoFit/>
+          </a:bodyPr>
+          <a:lstStyle/>
+          <a:p>
+            <a:pPr>
+              <a:defRPr sz="1200"/>
+            </a:pPr>
+            <a:r>
+              <a:t>Contact</a:t>
             </a:r>
           </a:p>
         </p:txBody>
@@ -4993,7 +5389,7 @@
           </a:p>
           <a:p>
             <a:r>
-              <a:t>Independent, free, learning-only student project. Respects every company, tradition, and vendor. Trademarks and sources belong to their owners. Not sold. Concerns are handled by correcting or removing content promptly vi</a:t>
+              <a:t>Independent, free, learning-only student project. Respects every company and vendor. Trademarks belong to their owners. Not affiliated or endorsed. Concerns are removed or corrected promptly via the contact form at https</a:t>
             </a:r>
           </a:p>
         </p:txBody>
@@ -5026,7 +5422,7 @@
               <a:defRPr sz="1200"/>
             </a:pPr>
             <a:r>
-              <a:t>GitHub</a:t>
+              <a:t>Website</a:t>
             </a:r>
           </a:p>
         </p:txBody>
@@ -5059,7 +5455,7 @@
               <a:defRPr sz="1200"/>
             </a:pPr>
             <a:r>
-              <a:t>Website</a:t>
+              <a:t>GitHub</a:t>
             </a:r>
           </a:p>
         </p:txBody>
@@ -5092,7 +5488,7 @@
               <a:defRPr sz="1200"/>
             </a:pPr>
             <a:r>
-              <a:t>X</a:t>
+              <a:t>Profile</a:t>
             </a:r>
           </a:p>
         </p:txBody>
@@ -5125,7 +5521,7 @@
               <a:defRPr sz="1200"/>
             </a:pPr>
             <a:r>
-              <a:t>LinkedIn</a:t>
+              <a:t>X</a:t>
             </a:r>
           </a:p>
         </p:txBody>
@@ -5158,7 +5554,73 @@
               <a:defRPr sz="1200"/>
             </a:pPr>
             <a:r>
+              <a:t>LinkedIn</a:t>
+            </a:r>
+          </a:p>
+        </p:txBody>
+      </p:sp>
+      <p:sp>
+        <p:nvSpPr>
+          <p:cNvPr id="10" name="TextBox 9">
+            <a:hlinkClick r:id="rId7"/>
+          </p:cNvPr>
+          <p:cNvSpPr txBox="1"/>
+          <p:nvPr/>
+        </p:nvSpPr>
+        <p:spPr>
+          <a:xfrm>
+            <a:off x="10972800" y="6355080"/>
+            <a:ext cx="2011680" cy="320040"/>
+          </a:xfrm>
+          <a:prstGeom prst="rect">
+            <a:avLst/>
+          </a:prstGeom>
+          <a:noFill/>
+        </p:spPr>
+        <p:txBody>
+          <a:bodyPr wrap="none">
+            <a:spAutoFit/>
+          </a:bodyPr>
+          <a:lstStyle/>
+          <a:p>
+            <a:pPr>
+              <a:defRPr sz="1200"/>
+            </a:pPr>
+            <a:r>
               <a:t>Hugging Face</a:t>
+            </a:r>
+          </a:p>
+        </p:txBody>
+      </p:sp>
+      <p:sp>
+        <p:nvSpPr>
+          <p:cNvPr id="11" name="TextBox 10">
+            <a:hlinkClick r:id="rId8"/>
+          </p:cNvPr>
+          <p:cNvSpPr txBox="1"/>
+          <p:nvPr/>
+        </p:nvSpPr>
+        <p:spPr>
+          <a:xfrm>
+            <a:off x="13075920" y="6355080"/>
+            <a:ext cx="2011680" cy="320040"/>
+          </a:xfrm>
+          <a:prstGeom prst="rect">
+            <a:avLst/>
+          </a:prstGeom>
+          <a:noFill/>
+        </p:spPr>
+        <p:txBody>
+          <a:bodyPr wrap="none">
+            <a:spAutoFit/>
+          </a:bodyPr>
+          <a:lstStyle/>
+          <a:p>
+            <a:pPr>
+              <a:defRPr sz="1200"/>
+            </a:pPr>
+            <a:r>
+              <a:t>Contact</a:t>
             </a:r>
           </a:p>
         </p:txBody>

</xml_diff>

<commit_message>
Add the tour, read-along guide, room exports, and legal page.
Keep only the three brand links, dock the guide on the right edge, and ship an installable web app with prepared publishing notes.

Co-authored-by: CYPHER0X9 <cipher0x9@users.noreply.github.com>
</commit_message>
<xml_diff>
--- a/downloads/ba-study-deck.pptx
+++ b/downloads/ba-study-deck.pptx
@@ -3307,138 +3307,6 @@
           </a:p>
         </p:txBody>
       </p:sp>
-      <p:sp>
-        <p:nvSpPr>
-          <p:cNvPr id="8" name="TextBox 7">
-            <a:hlinkClick r:id="rId5"/>
-          </p:cNvPr>
-          <p:cNvSpPr txBox="1"/>
-          <p:nvPr/>
-        </p:nvSpPr>
-        <p:spPr>
-          <a:xfrm>
-            <a:off x="6766560" y="6355080"/>
-            <a:ext cx="2011680" cy="320040"/>
-          </a:xfrm>
-          <a:prstGeom prst="rect">
-            <a:avLst/>
-          </a:prstGeom>
-          <a:noFill/>
-        </p:spPr>
-        <p:txBody>
-          <a:bodyPr wrap="none">
-            <a:spAutoFit/>
-          </a:bodyPr>
-          <a:lstStyle/>
-          <a:p>
-            <a:pPr>
-              <a:defRPr sz="1200"/>
-            </a:pPr>
-            <a:r>
-              <a:t>X</a:t>
-            </a:r>
-          </a:p>
-        </p:txBody>
-      </p:sp>
-      <p:sp>
-        <p:nvSpPr>
-          <p:cNvPr id="9" name="TextBox 8">
-            <a:hlinkClick r:id="rId6"/>
-          </p:cNvPr>
-          <p:cNvSpPr txBox="1"/>
-          <p:nvPr/>
-        </p:nvSpPr>
-        <p:spPr>
-          <a:xfrm>
-            <a:off x="8869680" y="6355080"/>
-            <a:ext cx="2011680" cy="320040"/>
-          </a:xfrm>
-          <a:prstGeom prst="rect">
-            <a:avLst/>
-          </a:prstGeom>
-          <a:noFill/>
-        </p:spPr>
-        <p:txBody>
-          <a:bodyPr wrap="none">
-            <a:spAutoFit/>
-          </a:bodyPr>
-          <a:lstStyle/>
-          <a:p>
-            <a:pPr>
-              <a:defRPr sz="1200"/>
-            </a:pPr>
-            <a:r>
-              <a:t>LinkedIn</a:t>
-            </a:r>
-          </a:p>
-        </p:txBody>
-      </p:sp>
-      <p:sp>
-        <p:nvSpPr>
-          <p:cNvPr id="10" name="TextBox 9">
-            <a:hlinkClick r:id="rId7"/>
-          </p:cNvPr>
-          <p:cNvSpPr txBox="1"/>
-          <p:nvPr/>
-        </p:nvSpPr>
-        <p:spPr>
-          <a:xfrm>
-            <a:off x="10972800" y="6355080"/>
-            <a:ext cx="2011680" cy="320040"/>
-          </a:xfrm>
-          <a:prstGeom prst="rect">
-            <a:avLst/>
-          </a:prstGeom>
-          <a:noFill/>
-        </p:spPr>
-        <p:txBody>
-          <a:bodyPr wrap="none">
-            <a:spAutoFit/>
-          </a:bodyPr>
-          <a:lstStyle/>
-          <a:p>
-            <a:pPr>
-              <a:defRPr sz="1200"/>
-            </a:pPr>
-            <a:r>
-              <a:t>Hugging Face</a:t>
-            </a:r>
-          </a:p>
-        </p:txBody>
-      </p:sp>
-      <p:sp>
-        <p:nvSpPr>
-          <p:cNvPr id="11" name="TextBox 10">
-            <a:hlinkClick r:id="rId8"/>
-          </p:cNvPr>
-          <p:cNvSpPr txBox="1"/>
-          <p:nvPr/>
-        </p:nvSpPr>
-        <p:spPr>
-          <a:xfrm>
-            <a:off x="13075920" y="6355080"/>
-            <a:ext cx="2011680" cy="320040"/>
-          </a:xfrm>
-          <a:prstGeom prst="rect">
-            <a:avLst/>
-          </a:prstGeom>
-          <a:noFill/>
-        </p:spPr>
-        <p:txBody>
-          <a:bodyPr wrap="none">
-            <a:spAutoFit/>
-          </a:bodyPr>
-          <a:lstStyle/>
-          <a:p>
-            <a:pPr>
-              <a:defRPr sz="1200"/>
-            </a:pPr>
-            <a:r>
-              <a:t>Contact</a:t>
-            </a:r>
-          </a:p>
-        </p:txBody>
-      </p:sp>
     </p:spTree>
   </p:cSld>
   <p:clrMapOvr>
@@ -3670,138 +3538,6 @@
           </a:p>
         </p:txBody>
       </p:sp>
-      <p:sp>
-        <p:nvSpPr>
-          <p:cNvPr id="8" name="TextBox 7">
-            <a:hlinkClick r:id="rId5"/>
-          </p:cNvPr>
-          <p:cNvSpPr txBox="1"/>
-          <p:nvPr/>
-        </p:nvSpPr>
-        <p:spPr>
-          <a:xfrm>
-            <a:off x="6766560" y="6355080"/>
-            <a:ext cx="2011680" cy="320040"/>
-          </a:xfrm>
-          <a:prstGeom prst="rect">
-            <a:avLst/>
-          </a:prstGeom>
-          <a:noFill/>
-        </p:spPr>
-        <p:txBody>
-          <a:bodyPr wrap="none">
-            <a:spAutoFit/>
-          </a:bodyPr>
-          <a:lstStyle/>
-          <a:p>
-            <a:pPr>
-              <a:defRPr sz="1200"/>
-            </a:pPr>
-            <a:r>
-              <a:t>X</a:t>
-            </a:r>
-          </a:p>
-        </p:txBody>
-      </p:sp>
-      <p:sp>
-        <p:nvSpPr>
-          <p:cNvPr id="9" name="TextBox 8">
-            <a:hlinkClick r:id="rId6"/>
-          </p:cNvPr>
-          <p:cNvSpPr txBox="1"/>
-          <p:nvPr/>
-        </p:nvSpPr>
-        <p:spPr>
-          <a:xfrm>
-            <a:off x="8869680" y="6355080"/>
-            <a:ext cx="2011680" cy="320040"/>
-          </a:xfrm>
-          <a:prstGeom prst="rect">
-            <a:avLst/>
-          </a:prstGeom>
-          <a:noFill/>
-        </p:spPr>
-        <p:txBody>
-          <a:bodyPr wrap="none">
-            <a:spAutoFit/>
-          </a:bodyPr>
-          <a:lstStyle/>
-          <a:p>
-            <a:pPr>
-              <a:defRPr sz="1200"/>
-            </a:pPr>
-            <a:r>
-              <a:t>LinkedIn</a:t>
-            </a:r>
-          </a:p>
-        </p:txBody>
-      </p:sp>
-      <p:sp>
-        <p:nvSpPr>
-          <p:cNvPr id="10" name="TextBox 9">
-            <a:hlinkClick r:id="rId7"/>
-          </p:cNvPr>
-          <p:cNvSpPr txBox="1"/>
-          <p:nvPr/>
-        </p:nvSpPr>
-        <p:spPr>
-          <a:xfrm>
-            <a:off x="10972800" y="6355080"/>
-            <a:ext cx="2011680" cy="320040"/>
-          </a:xfrm>
-          <a:prstGeom prst="rect">
-            <a:avLst/>
-          </a:prstGeom>
-          <a:noFill/>
-        </p:spPr>
-        <p:txBody>
-          <a:bodyPr wrap="none">
-            <a:spAutoFit/>
-          </a:bodyPr>
-          <a:lstStyle/>
-          <a:p>
-            <a:pPr>
-              <a:defRPr sz="1200"/>
-            </a:pPr>
-            <a:r>
-              <a:t>Hugging Face</a:t>
-            </a:r>
-          </a:p>
-        </p:txBody>
-      </p:sp>
-      <p:sp>
-        <p:nvSpPr>
-          <p:cNvPr id="11" name="TextBox 10">
-            <a:hlinkClick r:id="rId8"/>
-          </p:cNvPr>
-          <p:cNvSpPr txBox="1"/>
-          <p:nvPr/>
-        </p:nvSpPr>
-        <p:spPr>
-          <a:xfrm>
-            <a:off x="13075920" y="6355080"/>
-            <a:ext cx="2011680" cy="320040"/>
-          </a:xfrm>
-          <a:prstGeom prst="rect">
-            <a:avLst/>
-          </a:prstGeom>
-          <a:noFill/>
-        </p:spPr>
-        <p:txBody>
-          <a:bodyPr wrap="none">
-            <a:spAutoFit/>
-          </a:bodyPr>
-          <a:lstStyle/>
-          <a:p>
-            <a:pPr>
-              <a:defRPr sz="1200"/>
-            </a:pPr>
-            <a:r>
-              <a:t>Contact</a:t>
-            </a:r>
-          </a:p>
-        </p:txBody>
-      </p:sp>
     </p:spTree>
   </p:cSld>
   <p:clrMapOvr>
@@ -4041,138 +3777,6 @@
           </a:p>
         </p:txBody>
       </p:sp>
-      <p:sp>
-        <p:nvSpPr>
-          <p:cNvPr id="8" name="TextBox 7">
-            <a:hlinkClick r:id="rId5"/>
-          </p:cNvPr>
-          <p:cNvSpPr txBox="1"/>
-          <p:nvPr/>
-        </p:nvSpPr>
-        <p:spPr>
-          <a:xfrm>
-            <a:off x="6766560" y="6355080"/>
-            <a:ext cx="2011680" cy="320040"/>
-          </a:xfrm>
-          <a:prstGeom prst="rect">
-            <a:avLst/>
-          </a:prstGeom>
-          <a:noFill/>
-        </p:spPr>
-        <p:txBody>
-          <a:bodyPr wrap="none">
-            <a:spAutoFit/>
-          </a:bodyPr>
-          <a:lstStyle/>
-          <a:p>
-            <a:pPr>
-              <a:defRPr sz="1200"/>
-            </a:pPr>
-            <a:r>
-              <a:t>X</a:t>
-            </a:r>
-          </a:p>
-        </p:txBody>
-      </p:sp>
-      <p:sp>
-        <p:nvSpPr>
-          <p:cNvPr id="9" name="TextBox 8">
-            <a:hlinkClick r:id="rId6"/>
-          </p:cNvPr>
-          <p:cNvSpPr txBox="1"/>
-          <p:nvPr/>
-        </p:nvSpPr>
-        <p:spPr>
-          <a:xfrm>
-            <a:off x="8869680" y="6355080"/>
-            <a:ext cx="2011680" cy="320040"/>
-          </a:xfrm>
-          <a:prstGeom prst="rect">
-            <a:avLst/>
-          </a:prstGeom>
-          <a:noFill/>
-        </p:spPr>
-        <p:txBody>
-          <a:bodyPr wrap="none">
-            <a:spAutoFit/>
-          </a:bodyPr>
-          <a:lstStyle/>
-          <a:p>
-            <a:pPr>
-              <a:defRPr sz="1200"/>
-            </a:pPr>
-            <a:r>
-              <a:t>LinkedIn</a:t>
-            </a:r>
-          </a:p>
-        </p:txBody>
-      </p:sp>
-      <p:sp>
-        <p:nvSpPr>
-          <p:cNvPr id="10" name="TextBox 9">
-            <a:hlinkClick r:id="rId7"/>
-          </p:cNvPr>
-          <p:cNvSpPr txBox="1"/>
-          <p:nvPr/>
-        </p:nvSpPr>
-        <p:spPr>
-          <a:xfrm>
-            <a:off x="10972800" y="6355080"/>
-            <a:ext cx="2011680" cy="320040"/>
-          </a:xfrm>
-          <a:prstGeom prst="rect">
-            <a:avLst/>
-          </a:prstGeom>
-          <a:noFill/>
-        </p:spPr>
-        <p:txBody>
-          <a:bodyPr wrap="none">
-            <a:spAutoFit/>
-          </a:bodyPr>
-          <a:lstStyle/>
-          <a:p>
-            <a:pPr>
-              <a:defRPr sz="1200"/>
-            </a:pPr>
-            <a:r>
-              <a:t>Hugging Face</a:t>
-            </a:r>
-          </a:p>
-        </p:txBody>
-      </p:sp>
-      <p:sp>
-        <p:nvSpPr>
-          <p:cNvPr id="11" name="TextBox 10">
-            <a:hlinkClick r:id="rId8"/>
-          </p:cNvPr>
-          <p:cNvSpPr txBox="1"/>
-          <p:nvPr/>
-        </p:nvSpPr>
-        <p:spPr>
-          <a:xfrm>
-            <a:off x="13075920" y="6355080"/>
-            <a:ext cx="2011680" cy="320040"/>
-          </a:xfrm>
-          <a:prstGeom prst="rect">
-            <a:avLst/>
-          </a:prstGeom>
-          <a:noFill/>
-        </p:spPr>
-        <p:txBody>
-          <a:bodyPr wrap="none">
-            <a:spAutoFit/>
-          </a:bodyPr>
-          <a:lstStyle/>
-          <a:p>
-            <a:pPr>
-              <a:defRPr sz="1200"/>
-            </a:pPr>
-            <a:r>
-              <a:t>Contact</a:t>
-            </a:r>
-          </a:p>
-        </p:txBody>
-      </p:sp>
     </p:spTree>
   </p:cSld>
   <p:clrMapOvr>
@@ -4404,138 +4008,6 @@
           </a:p>
         </p:txBody>
       </p:sp>
-      <p:sp>
-        <p:nvSpPr>
-          <p:cNvPr id="8" name="TextBox 7">
-            <a:hlinkClick r:id="rId5"/>
-          </p:cNvPr>
-          <p:cNvSpPr txBox="1"/>
-          <p:nvPr/>
-        </p:nvSpPr>
-        <p:spPr>
-          <a:xfrm>
-            <a:off x="6766560" y="6355080"/>
-            <a:ext cx="2011680" cy="320040"/>
-          </a:xfrm>
-          <a:prstGeom prst="rect">
-            <a:avLst/>
-          </a:prstGeom>
-          <a:noFill/>
-        </p:spPr>
-        <p:txBody>
-          <a:bodyPr wrap="none">
-            <a:spAutoFit/>
-          </a:bodyPr>
-          <a:lstStyle/>
-          <a:p>
-            <a:pPr>
-              <a:defRPr sz="1200"/>
-            </a:pPr>
-            <a:r>
-              <a:t>X</a:t>
-            </a:r>
-          </a:p>
-        </p:txBody>
-      </p:sp>
-      <p:sp>
-        <p:nvSpPr>
-          <p:cNvPr id="9" name="TextBox 8">
-            <a:hlinkClick r:id="rId6"/>
-          </p:cNvPr>
-          <p:cNvSpPr txBox="1"/>
-          <p:nvPr/>
-        </p:nvSpPr>
-        <p:spPr>
-          <a:xfrm>
-            <a:off x="8869680" y="6355080"/>
-            <a:ext cx="2011680" cy="320040"/>
-          </a:xfrm>
-          <a:prstGeom prst="rect">
-            <a:avLst/>
-          </a:prstGeom>
-          <a:noFill/>
-        </p:spPr>
-        <p:txBody>
-          <a:bodyPr wrap="none">
-            <a:spAutoFit/>
-          </a:bodyPr>
-          <a:lstStyle/>
-          <a:p>
-            <a:pPr>
-              <a:defRPr sz="1200"/>
-            </a:pPr>
-            <a:r>
-              <a:t>LinkedIn</a:t>
-            </a:r>
-          </a:p>
-        </p:txBody>
-      </p:sp>
-      <p:sp>
-        <p:nvSpPr>
-          <p:cNvPr id="10" name="TextBox 9">
-            <a:hlinkClick r:id="rId7"/>
-          </p:cNvPr>
-          <p:cNvSpPr txBox="1"/>
-          <p:nvPr/>
-        </p:nvSpPr>
-        <p:spPr>
-          <a:xfrm>
-            <a:off x="10972800" y="6355080"/>
-            <a:ext cx="2011680" cy="320040"/>
-          </a:xfrm>
-          <a:prstGeom prst="rect">
-            <a:avLst/>
-          </a:prstGeom>
-          <a:noFill/>
-        </p:spPr>
-        <p:txBody>
-          <a:bodyPr wrap="none">
-            <a:spAutoFit/>
-          </a:bodyPr>
-          <a:lstStyle/>
-          <a:p>
-            <a:pPr>
-              <a:defRPr sz="1200"/>
-            </a:pPr>
-            <a:r>
-              <a:t>Hugging Face</a:t>
-            </a:r>
-          </a:p>
-        </p:txBody>
-      </p:sp>
-      <p:sp>
-        <p:nvSpPr>
-          <p:cNvPr id="11" name="TextBox 10">
-            <a:hlinkClick r:id="rId8"/>
-          </p:cNvPr>
-          <p:cNvSpPr txBox="1"/>
-          <p:nvPr/>
-        </p:nvSpPr>
-        <p:spPr>
-          <a:xfrm>
-            <a:off x="13075920" y="6355080"/>
-            <a:ext cx="2011680" cy="320040"/>
-          </a:xfrm>
-          <a:prstGeom prst="rect">
-            <a:avLst/>
-          </a:prstGeom>
-          <a:noFill/>
-        </p:spPr>
-        <p:txBody>
-          <a:bodyPr wrap="none">
-            <a:spAutoFit/>
-          </a:bodyPr>
-          <a:lstStyle/>
-          <a:p>
-            <a:pPr>
-              <a:defRPr sz="1200"/>
-            </a:pPr>
-            <a:r>
-              <a:t>Contact</a:t>
-            </a:r>
-          </a:p>
-        </p:txBody>
-      </p:sp>
     </p:spTree>
   </p:cSld>
   <p:clrMapOvr>
@@ -4767,138 +4239,6 @@
           </a:p>
         </p:txBody>
       </p:sp>
-      <p:sp>
-        <p:nvSpPr>
-          <p:cNvPr id="8" name="TextBox 7">
-            <a:hlinkClick r:id="rId5"/>
-          </p:cNvPr>
-          <p:cNvSpPr txBox="1"/>
-          <p:nvPr/>
-        </p:nvSpPr>
-        <p:spPr>
-          <a:xfrm>
-            <a:off x="6766560" y="6355080"/>
-            <a:ext cx="2011680" cy="320040"/>
-          </a:xfrm>
-          <a:prstGeom prst="rect">
-            <a:avLst/>
-          </a:prstGeom>
-          <a:noFill/>
-        </p:spPr>
-        <p:txBody>
-          <a:bodyPr wrap="none">
-            <a:spAutoFit/>
-          </a:bodyPr>
-          <a:lstStyle/>
-          <a:p>
-            <a:pPr>
-              <a:defRPr sz="1200"/>
-            </a:pPr>
-            <a:r>
-              <a:t>X</a:t>
-            </a:r>
-          </a:p>
-        </p:txBody>
-      </p:sp>
-      <p:sp>
-        <p:nvSpPr>
-          <p:cNvPr id="9" name="TextBox 8">
-            <a:hlinkClick r:id="rId6"/>
-          </p:cNvPr>
-          <p:cNvSpPr txBox="1"/>
-          <p:nvPr/>
-        </p:nvSpPr>
-        <p:spPr>
-          <a:xfrm>
-            <a:off x="8869680" y="6355080"/>
-            <a:ext cx="2011680" cy="320040"/>
-          </a:xfrm>
-          <a:prstGeom prst="rect">
-            <a:avLst/>
-          </a:prstGeom>
-          <a:noFill/>
-        </p:spPr>
-        <p:txBody>
-          <a:bodyPr wrap="none">
-            <a:spAutoFit/>
-          </a:bodyPr>
-          <a:lstStyle/>
-          <a:p>
-            <a:pPr>
-              <a:defRPr sz="1200"/>
-            </a:pPr>
-            <a:r>
-              <a:t>LinkedIn</a:t>
-            </a:r>
-          </a:p>
-        </p:txBody>
-      </p:sp>
-      <p:sp>
-        <p:nvSpPr>
-          <p:cNvPr id="10" name="TextBox 9">
-            <a:hlinkClick r:id="rId7"/>
-          </p:cNvPr>
-          <p:cNvSpPr txBox="1"/>
-          <p:nvPr/>
-        </p:nvSpPr>
-        <p:spPr>
-          <a:xfrm>
-            <a:off x="10972800" y="6355080"/>
-            <a:ext cx="2011680" cy="320040"/>
-          </a:xfrm>
-          <a:prstGeom prst="rect">
-            <a:avLst/>
-          </a:prstGeom>
-          <a:noFill/>
-        </p:spPr>
-        <p:txBody>
-          <a:bodyPr wrap="none">
-            <a:spAutoFit/>
-          </a:bodyPr>
-          <a:lstStyle/>
-          <a:p>
-            <a:pPr>
-              <a:defRPr sz="1200"/>
-            </a:pPr>
-            <a:r>
-              <a:t>Hugging Face</a:t>
-            </a:r>
-          </a:p>
-        </p:txBody>
-      </p:sp>
-      <p:sp>
-        <p:nvSpPr>
-          <p:cNvPr id="11" name="TextBox 10">
-            <a:hlinkClick r:id="rId8"/>
-          </p:cNvPr>
-          <p:cNvSpPr txBox="1"/>
-          <p:nvPr/>
-        </p:nvSpPr>
-        <p:spPr>
-          <a:xfrm>
-            <a:off x="13075920" y="6355080"/>
-            <a:ext cx="2011680" cy="320040"/>
-          </a:xfrm>
-          <a:prstGeom prst="rect">
-            <a:avLst/>
-          </a:prstGeom>
-          <a:noFill/>
-        </p:spPr>
-        <p:txBody>
-          <a:bodyPr wrap="none">
-            <a:spAutoFit/>
-          </a:bodyPr>
-          <a:lstStyle/>
-          <a:p>
-            <a:pPr>
-              <a:defRPr sz="1200"/>
-            </a:pPr>
-            <a:r>
-              <a:t>Contact</a:t>
-            </a:r>
-          </a:p>
-        </p:txBody>
-      </p:sp>
     </p:spTree>
   </p:cSld>
   <p:clrMapOvr>
@@ -5130,138 +4470,6 @@
           </a:p>
         </p:txBody>
       </p:sp>
-      <p:sp>
-        <p:nvSpPr>
-          <p:cNvPr id="8" name="TextBox 7">
-            <a:hlinkClick r:id="rId5"/>
-          </p:cNvPr>
-          <p:cNvSpPr txBox="1"/>
-          <p:nvPr/>
-        </p:nvSpPr>
-        <p:spPr>
-          <a:xfrm>
-            <a:off x="6766560" y="6355080"/>
-            <a:ext cx="2011680" cy="320040"/>
-          </a:xfrm>
-          <a:prstGeom prst="rect">
-            <a:avLst/>
-          </a:prstGeom>
-          <a:noFill/>
-        </p:spPr>
-        <p:txBody>
-          <a:bodyPr wrap="none">
-            <a:spAutoFit/>
-          </a:bodyPr>
-          <a:lstStyle/>
-          <a:p>
-            <a:pPr>
-              <a:defRPr sz="1200"/>
-            </a:pPr>
-            <a:r>
-              <a:t>X</a:t>
-            </a:r>
-          </a:p>
-        </p:txBody>
-      </p:sp>
-      <p:sp>
-        <p:nvSpPr>
-          <p:cNvPr id="9" name="TextBox 8">
-            <a:hlinkClick r:id="rId6"/>
-          </p:cNvPr>
-          <p:cNvSpPr txBox="1"/>
-          <p:nvPr/>
-        </p:nvSpPr>
-        <p:spPr>
-          <a:xfrm>
-            <a:off x="8869680" y="6355080"/>
-            <a:ext cx="2011680" cy="320040"/>
-          </a:xfrm>
-          <a:prstGeom prst="rect">
-            <a:avLst/>
-          </a:prstGeom>
-          <a:noFill/>
-        </p:spPr>
-        <p:txBody>
-          <a:bodyPr wrap="none">
-            <a:spAutoFit/>
-          </a:bodyPr>
-          <a:lstStyle/>
-          <a:p>
-            <a:pPr>
-              <a:defRPr sz="1200"/>
-            </a:pPr>
-            <a:r>
-              <a:t>LinkedIn</a:t>
-            </a:r>
-          </a:p>
-        </p:txBody>
-      </p:sp>
-      <p:sp>
-        <p:nvSpPr>
-          <p:cNvPr id="10" name="TextBox 9">
-            <a:hlinkClick r:id="rId7"/>
-          </p:cNvPr>
-          <p:cNvSpPr txBox="1"/>
-          <p:nvPr/>
-        </p:nvSpPr>
-        <p:spPr>
-          <a:xfrm>
-            <a:off x="10972800" y="6355080"/>
-            <a:ext cx="2011680" cy="320040"/>
-          </a:xfrm>
-          <a:prstGeom prst="rect">
-            <a:avLst/>
-          </a:prstGeom>
-          <a:noFill/>
-        </p:spPr>
-        <p:txBody>
-          <a:bodyPr wrap="none">
-            <a:spAutoFit/>
-          </a:bodyPr>
-          <a:lstStyle/>
-          <a:p>
-            <a:pPr>
-              <a:defRPr sz="1200"/>
-            </a:pPr>
-            <a:r>
-              <a:t>Hugging Face</a:t>
-            </a:r>
-          </a:p>
-        </p:txBody>
-      </p:sp>
-      <p:sp>
-        <p:nvSpPr>
-          <p:cNvPr id="11" name="TextBox 10">
-            <a:hlinkClick r:id="rId8"/>
-          </p:cNvPr>
-          <p:cNvSpPr txBox="1"/>
-          <p:nvPr/>
-        </p:nvSpPr>
-        <p:spPr>
-          <a:xfrm>
-            <a:off x="13075920" y="6355080"/>
-            <a:ext cx="2011680" cy="320040"/>
-          </a:xfrm>
-          <a:prstGeom prst="rect">
-            <a:avLst/>
-          </a:prstGeom>
-          <a:noFill/>
-        </p:spPr>
-        <p:txBody>
-          <a:bodyPr wrap="none">
-            <a:spAutoFit/>
-          </a:bodyPr>
-          <a:lstStyle/>
-          <a:p>
-            <a:pPr>
-              <a:defRPr sz="1200"/>
-            </a:pPr>
-            <a:r>
-              <a:t>Contact</a:t>
-            </a:r>
-          </a:p>
-        </p:txBody>
-      </p:sp>
     </p:spTree>
   </p:cSld>
   <p:clrMapOvr>
@@ -5489,138 +4697,6 @@
             </a:pPr>
             <a:r>
               <a:t>Profile</a:t>
-            </a:r>
-          </a:p>
-        </p:txBody>
-      </p:sp>
-      <p:sp>
-        <p:nvSpPr>
-          <p:cNvPr id="8" name="TextBox 7">
-            <a:hlinkClick r:id="rId5"/>
-          </p:cNvPr>
-          <p:cNvSpPr txBox="1"/>
-          <p:nvPr/>
-        </p:nvSpPr>
-        <p:spPr>
-          <a:xfrm>
-            <a:off x="6766560" y="6355080"/>
-            <a:ext cx="2011680" cy="320040"/>
-          </a:xfrm>
-          <a:prstGeom prst="rect">
-            <a:avLst/>
-          </a:prstGeom>
-          <a:noFill/>
-        </p:spPr>
-        <p:txBody>
-          <a:bodyPr wrap="none">
-            <a:spAutoFit/>
-          </a:bodyPr>
-          <a:lstStyle/>
-          <a:p>
-            <a:pPr>
-              <a:defRPr sz="1200"/>
-            </a:pPr>
-            <a:r>
-              <a:t>X</a:t>
-            </a:r>
-          </a:p>
-        </p:txBody>
-      </p:sp>
-      <p:sp>
-        <p:nvSpPr>
-          <p:cNvPr id="9" name="TextBox 8">
-            <a:hlinkClick r:id="rId6"/>
-          </p:cNvPr>
-          <p:cNvSpPr txBox="1"/>
-          <p:nvPr/>
-        </p:nvSpPr>
-        <p:spPr>
-          <a:xfrm>
-            <a:off x="8869680" y="6355080"/>
-            <a:ext cx="2011680" cy="320040"/>
-          </a:xfrm>
-          <a:prstGeom prst="rect">
-            <a:avLst/>
-          </a:prstGeom>
-          <a:noFill/>
-        </p:spPr>
-        <p:txBody>
-          <a:bodyPr wrap="none">
-            <a:spAutoFit/>
-          </a:bodyPr>
-          <a:lstStyle/>
-          <a:p>
-            <a:pPr>
-              <a:defRPr sz="1200"/>
-            </a:pPr>
-            <a:r>
-              <a:t>LinkedIn</a:t>
-            </a:r>
-          </a:p>
-        </p:txBody>
-      </p:sp>
-      <p:sp>
-        <p:nvSpPr>
-          <p:cNvPr id="10" name="TextBox 9">
-            <a:hlinkClick r:id="rId7"/>
-          </p:cNvPr>
-          <p:cNvSpPr txBox="1"/>
-          <p:nvPr/>
-        </p:nvSpPr>
-        <p:spPr>
-          <a:xfrm>
-            <a:off x="10972800" y="6355080"/>
-            <a:ext cx="2011680" cy="320040"/>
-          </a:xfrm>
-          <a:prstGeom prst="rect">
-            <a:avLst/>
-          </a:prstGeom>
-          <a:noFill/>
-        </p:spPr>
-        <p:txBody>
-          <a:bodyPr wrap="none">
-            <a:spAutoFit/>
-          </a:bodyPr>
-          <a:lstStyle/>
-          <a:p>
-            <a:pPr>
-              <a:defRPr sz="1200"/>
-            </a:pPr>
-            <a:r>
-              <a:t>Hugging Face</a:t>
-            </a:r>
-          </a:p>
-        </p:txBody>
-      </p:sp>
-      <p:sp>
-        <p:nvSpPr>
-          <p:cNvPr id="11" name="TextBox 10">
-            <a:hlinkClick r:id="rId8"/>
-          </p:cNvPr>
-          <p:cNvSpPr txBox="1"/>
-          <p:nvPr/>
-        </p:nvSpPr>
-        <p:spPr>
-          <a:xfrm>
-            <a:off x="13075920" y="6355080"/>
-            <a:ext cx="2011680" cy="320040"/>
-          </a:xfrm>
-          <a:prstGeom prst="rect">
-            <a:avLst/>
-          </a:prstGeom>
-          <a:noFill/>
-        </p:spPr>
-        <p:txBody>
-          <a:bodyPr wrap="none">
-            <a:spAutoFit/>
-          </a:bodyPr>
-          <a:lstStyle/>
-          <a:p>
-            <a:pPr>
-              <a:defRPr sz="1200"/>
-            </a:pPr>
-            <a:r>
-              <a:t>Contact</a:t>
             </a:r>
           </a:p>
         </p:txBody>

</xml_diff>

<commit_message>
End every room and download with opened sources.
Each sheet, card, chapter, and room export closes with Sources and go deeper. Per-room sources.json is rendered on the page. A link that did not open is marked confirm and is not given a URL.

Co-authored-by: CYPHER0X9 <cipher0x9@users.noreply.github.com>
</commit_message>
<xml_diff>
--- a/downloads/ba-study-deck.pptx
+++ b/downloads/ba-study-deck.pptx
@@ -12,6 +12,9 @@
     <p:sldId id="260" r:id="rId11"/>
     <p:sldId id="261" r:id="rId12"/>
     <p:sldId id="262" r:id="rId13"/>
+    <p:sldId id="263" r:id="rId14"/>
+    <p:sldId id="264" r:id="rId15"/>
+    <p:sldId id="265" r:id="rId16"/>
   </p:sldIdLst>
   <p:sldSz cx="12191695" cy="6858000" type="screen4x3"/>
   <p:notesSz cx="6858000" cy="9144000"/>
@@ -3103,7 +3106,7 @@
         <p:spPr>
           <a:xfrm>
             <a:off x="457200" y="274320"/>
-            <a:ext cx="11155680" cy="731520"/>
+            <a:ext cx="11155680" cy="640080"/>
           </a:xfrm>
           <a:prstGeom prst="rect">
             <a:avLst/>
@@ -3133,8 +3136,8 @@
         </p:nvSpPr>
         <p:spPr>
           <a:xfrm>
-            <a:off x="548640" y="1188720"/>
-            <a:ext cx="10972800" cy="4206240"/>
+            <a:off x="548640" y="1051560"/>
+            <a:ext cx="10972800" cy="4297680"/>
           </a:xfrm>
           <a:prstGeom prst="rect">
             <a:avLst/>
@@ -3168,6 +3171,221 @@
             </a:pPr>
             <a:r>
               <a:t>Fees are cited. Unknowns stay unknown.</a:t>
+            </a:r>
+          </a:p>
+        </p:txBody>
+      </p:sp>
+      <p:sp>
+        <p:nvSpPr>
+          <p:cNvPr id="4" name="TextBox 3"/>
+          <p:cNvSpPr txBox="1"/>
+          <p:nvPr/>
+        </p:nvSpPr>
+        <p:spPr>
+          <a:xfrm>
+            <a:off x="457200" y="5623560"/>
+            <a:ext cx="11155680" cy="1005840"/>
+          </a:xfrm>
+          <a:prstGeom prst="rect">
+            <a:avLst/>
+          </a:prstGeom>
+          <a:noFill/>
+        </p:spPr>
+        <p:txBody>
+          <a:bodyPr wrap="square">
+            <a:spAutoFit/>
+          </a:bodyPr>
+          <a:lstStyle/>
+          <a:p>
+            <a:pPr>
+              <a:defRPr sz="1000"/>
+            </a:pPr>
+            <a:r>
+              <a:t>CypherMonkey Labs · © 2026 CypherMonkeyLabs</a:t>
+            </a:r>
+          </a:p>
+          <a:p>
+            <a:r>
+              <a:t>Independent, free, learning-only student project. Respects every company and vendor. Trademarks belong to their owners. Not affiliated or endorsed. Concerns are removed or corrected promptly via the contact form at https</a:t>
+            </a:r>
+          </a:p>
+        </p:txBody>
+      </p:sp>
+      <p:sp>
+        <p:nvSpPr>
+          <p:cNvPr id="5" name="TextBox 4">
+            <a:hlinkClick r:id="rId2"/>
+          </p:cNvPr>
+          <p:cNvSpPr txBox="1"/>
+          <p:nvPr/>
+        </p:nvSpPr>
+        <p:spPr>
+          <a:xfrm>
+            <a:off x="457200" y="6355080"/>
+            <a:ext cx="2011680" cy="320040"/>
+          </a:xfrm>
+          <a:prstGeom prst="rect">
+            <a:avLst/>
+          </a:prstGeom>
+          <a:noFill/>
+        </p:spPr>
+        <p:txBody>
+          <a:bodyPr wrap="none">
+            <a:spAutoFit/>
+          </a:bodyPr>
+          <a:lstStyle/>
+          <a:p>
+            <a:pPr>
+              <a:defRPr sz="1200"/>
+            </a:pPr>
+            <a:r>
+              <a:t>Website</a:t>
+            </a:r>
+          </a:p>
+        </p:txBody>
+      </p:sp>
+      <p:sp>
+        <p:nvSpPr>
+          <p:cNvPr id="6" name="TextBox 5">
+            <a:hlinkClick r:id="rId3"/>
+          </p:cNvPr>
+          <p:cNvSpPr txBox="1"/>
+          <p:nvPr/>
+        </p:nvSpPr>
+        <p:spPr>
+          <a:xfrm>
+            <a:off x="2560320" y="6355080"/>
+            <a:ext cx="2011680" cy="320040"/>
+          </a:xfrm>
+          <a:prstGeom prst="rect">
+            <a:avLst/>
+          </a:prstGeom>
+          <a:noFill/>
+        </p:spPr>
+        <p:txBody>
+          <a:bodyPr wrap="none">
+            <a:spAutoFit/>
+          </a:bodyPr>
+          <a:lstStyle/>
+          <a:p>
+            <a:pPr>
+              <a:defRPr sz="1200"/>
+            </a:pPr>
+            <a:r>
+              <a:t>GitHub</a:t>
+            </a:r>
+          </a:p>
+        </p:txBody>
+      </p:sp>
+      <p:sp>
+        <p:nvSpPr>
+          <p:cNvPr id="7" name="TextBox 6">
+            <a:hlinkClick r:id="rId4"/>
+          </p:cNvPr>
+          <p:cNvSpPr txBox="1"/>
+          <p:nvPr/>
+        </p:nvSpPr>
+        <p:spPr>
+          <a:xfrm>
+            <a:off x="4663440" y="6355080"/>
+            <a:ext cx="2011680" cy="320040"/>
+          </a:xfrm>
+          <a:prstGeom prst="rect">
+            <a:avLst/>
+          </a:prstGeom>
+          <a:noFill/>
+        </p:spPr>
+        <p:txBody>
+          <a:bodyPr wrap="none">
+            <a:spAutoFit/>
+          </a:bodyPr>
+          <a:lstStyle/>
+          <a:p>
+            <a:pPr>
+              <a:defRPr sz="1200"/>
+            </a:pPr>
+            <a:r>
+              <a:t>Profile</a:t>
+            </a:r>
+          </a:p>
+        </p:txBody>
+      </p:sp>
+    </p:spTree>
+  </p:cSld>
+  <p:clrMapOvr>
+    <a:masterClrMapping/>
+  </p:clrMapOvr>
+</p:sld>
+</file>
+
+<file path=ppt/slides/slide10.xml><?xml version="1.0" encoding="utf-8"?>
+<p:sld xmlns:a="http://schemas.openxmlformats.org/drawingml/2006/main" xmlns:p="http://schemas.openxmlformats.org/presentationml/2006/main" xmlns:r="http://schemas.openxmlformats.org/officeDocument/2006/relationships">
+  <p:cSld>
+    <p:spTree>
+      <p:nvGrpSpPr>
+        <p:cNvPr id="1" name=""/>
+        <p:cNvGrpSpPr/>
+        <p:nvPr/>
+      </p:nvGrpSpPr>
+      <p:grpSpPr/>
+      <p:sp>
+        <p:nvSpPr>
+          <p:cNvPr id="2" name="TextBox 1"/>
+          <p:cNvSpPr txBox="1"/>
+          <p:nvPr/>
+        </p:nvSpPr>
+        <p:spPr>
+          <a:xfrm>
+            <a:off x="457200" y="274320"/>
+            <a:ext cx="11155680" cy="640080"/>
+          </a:xfrm>
+          <a:prstGeom prst="rect">
+            <a:avLst/>
+          </a:prstGeom>
+          <a:noFill/>
+        </p:spPr>
+        <p:txBody>
+          <a:bodyPr wrap="none">
+            <a:spAutoFit/>
+          </a:bodyPr>
+          <a:lstStyle/>
+          <a:p>
+            <a:pPr>
+              <a:defRPr sz="2800" b="1"/>
+            </a:pPr>
+            <a:r>
+              <a:t>Sources and go deeper, continued</a:t>
+            </a:r>
+          </a:p>
+        </p:txBody>
+      </p:sp>
+      <p:sp>
+        <p:nvSpPr>
+          <p:cNvPr id="3" name="TextBox 2"/>
+          <p:cNvSpPr txBox="1"/>
+          <p:nvPr/>
+        </p:nvSpPr>
+        <p:spPr>
+          <a:xfrm>
+            <a:off x="548640" y="1051560"/>
+            <a:ext cx="10972800" cy="4297680"/>
+          </a:xfrm>
+          <a:prstGeom prst="rect">
+            <a:avLst/>
+          </a:prstGeom>
+          <a:noFill/>
+        </p:spPr>
+        <p:txBody>
+          <a:bodyPr wrap="square">
+            <a:spAutoFit/>
+          </a:bodyPr>
+          <a:lstStyle/>
+          <a:p>
+            <a:pPr>
+              <a:defRPr sz="1400"/>
+            </a:pPr>
+            <a:r>
+              <a:t>How to Meet WCAG, quick reference (official). https://www.w3.org/WAI/WCAG22/quickref/ last checked 2026-10.</a:t>
             </a:r>
           </a:p>
         </p:txBody>
@@ -3334,7 +3552,7 @@
         <p:spPr>
           <a:xfrm>
             <a:off x="457200" y="274320"/>
-            <a:ext cx="11155680" cy="731520"/>
+            <a:ext cx="11155680" cy="640080"/>
           </a:xfrm>
           <a:prstGeom prst="rect">
             <a:avLst/>
@@ -3364,8 +3582,8 @@
         </p:nvSpPr>
         <p:spPr>
           <a:xfrm>
-            <a:off x="548640" y="1188720"/>
-            <a:ext cx="10972800" cy="4206240"/>
+            <a:off x="548640" y="1051560"/>
+            <a:ext cx="10972800" cy="4297680"/>
           </a:xfrm>
           <a:prstGeom prst="rect">
             <a:avLst/>
@@ -3565,7 +3783,7 @@
         <p:spPr>
           <a:xfrm>
             <a:off x="457200" y="274320"/>
-            <a:ext cx="11155680" cy="731520"/>
+            <a:ext cx="11155680" cy="640080"/>
           </a:xfrm>
           <a:prstGeom prst="rect">
             <a:avLst/>
@@ -3595,8 +3813,8 @@
         </p:nvSpPr>
         <p:spPr>
           <a:xfrm>
-            <a:off x="548640" y="1188720"/>
-            <a:ext cx="10972800" cy="4206240"/>
+            <a:off x="548640" y="1051560"/>
+            <a:ext cx="10972800" cy="4297680"/>
           </a:xfrm>
           <a:prstGeom prst="rect">
             <a:avLst/>
@@ -3804,7 +4022,7 @@
         <p:spPr>
           <a:xfrm>
             <a:off x="457200" y="274320"/>
-            <a:ext cx="11155680" cy="731520"/>
+            <a:ext cx="11155680" cy="640080"/>
           </a:xfrm>
           <a:prstGeom prst="rect">
             <a:avLst/>
@@ -3834,8 +4052,8 @@
         </p:nvSpPr>
         <p:spPr>
           <a:xfrm>
-            <a:off x="548640" y="1188720"/>
-            <a:ext cx="10972800" cy="4206240"/>
+            <a:off x="548640" y="1051560"/>
+            <a:ext cx="10972800" cy="4297680"/>
           </a:xfrm>
           <a:prstGeom prst="rect">
             <a:avLst/>
@@ -4035,7 +4253,7 @@
         <p:spPr>
           <a:xfrm>
             <a:off x="457200" y="274320"/>
-            <a:ext cx="11155680" cy="731520"/>
+            <a:ext cx="11155680" cy="640080"/>
           </a:xfrm>
           <a:prstGeom prst="rect">
             <a:avLst/>
@@ -4065,8 +4283,8 @@
         </p:nvSpPr>
         <p:spPr>
           <a:xfrm>
-            <a:off x="548640" y="1188720"/>
-            <a:ext cx="10972800" cy="4206240"/>
+            <a:off x="548640" y="1051560"/>
+            <a:ext cx="10972800" cy="4297680"/>
           </a:xfrm>
           <a:prstGeom prst="rect">
             <a:avLst/>
@@ -4266,7 +4484,7 @@
         <p:spPr>
           <a:xfrm>
             <a:off x="457200" y="274320"/>
-            <a:ext cx="11155680" cy="731520"/>
+            <a:ext cx="11155680" cy="640080"/>
           </a:xfrm>
           <a:prstGeom prst="rect">
             <a:avLst/>
@@ -4296,8 +4514,8 @@
         </p:nvSpPr>
         <p:spPr>
           <a:xfrm>
-            <a:off x="548640" y="1188720"/>
-            <a:ext cx="10972800" cy="4206240"/>
+            <a:off x="548640" y="1051560"/>
+            <a:ext cx="10972800" cy="4297680"/>
           </a:xfrm>
           <a:prstGeom prst="rect">
             <a:avLst/>
@@ -4497,7 +4715,7 @@
         <p:spPr>
           <a:xfrm>
             <a:off x="457200" y="274320"/>
-            <a:ext cx="11155680" cy="731520"/>
+            <a:ext cx="11155680" cy="640080"/>
           </a:xfrm>
           <a:prstGeom prst="rect">
             <a:avLst/>
@@ -4527,8 +4745,8 @@
         </p:nvSpPr>
         <p:spPr>
           <a:xfrm>
-            <a:off x="548640" y="1188720"/>
-            <a:ext cx="10972800" cy="4206240"/>
+            <a:off x="548640" y="1051560"/>
+            <a:ext cx="10972800" cy="4297680"/>
           </a:xfrm>
           <a:prstGeom prst="rect">
             <a:avLst/>
@@ -4562,6 +4780,532 @@
             </a:pPr>
             <a:r>
               <a:t>Correct us via the contact form.</a:t>
+            </a:r>
+          </a:p>
+        </p:txBody>
+      </p:sp>
+      <p:sp>
+        <p:nvSpPr>
+          <p:cNvPr id="4" name="TextBox 3"/>
+          <p:cNvSpPr txBox="1"/>
+          <p:nvPr/>
+        </p:nvSpPr>
+        <p:spPr>
+          <a:xfrm>
+            <a:off x="457200" y="5623560"/>
+            <a:ext cx="11155680" cy="1005840"/>
+          </a:xfrm>
+          <a:prstGeom prst="rect">
+            <a:avLst/>
+          </a:prstGeom>
+          <a:noFill/>
+        </p:spPr>
+        <p:txBody>
+          <a:bodyPr wrap="square">
+            <a:spAutoFit/>
+          </a:bodyPr>
+          <a:lstStyle/>
+          <a:p>
+            <a:pPr>
+              <a:defRPr sz="1000"/>
+            </a:pPr>
+            <a:r>
+              <a:t>CypherMonkey Labs · © 2026 CypherMonkeyLabs</a:t>
+            </a:r>
+          </a:p>
+          <a:p>
+            <a:r>
+              <a:t>Independent, free, learning-only student project. Respects every company and vendor. Trademarks belong to their owners. Not affiliated or endorsed. Concerns are removed or corrected promptly via the contact form at https</a:t>
+            </a:r>
+          </a:p>
+        </p:txBody>
+      </p:sp>
+      <p:sp>
+        <p:nvSpPr>
+          <p:cNvPr id="5" name="TextBox 4">
+            <a:hlinkClick r:id="rId2"/>
+          </p:cNvPr>
+          <p:cNvSpPr txBox="1"/>
+          <p:nvPr/>
+        </p:nvSpPr>
+        <p:spPr>
+          <a:xfrm>
+            <a:off x="457200" y="6355080"/>
+            <a:ext cx="2011680" cy="320040"/>
+          </a:xfrm>
+          <a:prstGeom prst="rect">
+            <a:avLst/>
+          </a:prstGeom>
+          <a:noFill/>
+        </p:spPr>
+        <p:txBody>
+          <a:bodyPr wrap="none">
+            <a:spAutoFit/>
+          </a:bodyPr>
+          <a:lstStyle/>
+          <a:p>
+            <a:pPr>
+              <a:defRPr sz="1200"/>
+            </a:pPr>
+            <a:r>
+              <a:t>Website</a:t>
+            </a:r>
+          </a:p>
+        </p:txBody>
+      </p:sp>
+      <p:sp>
+        <p:nvSpPr>
+          <p:cNvPr id="6" name="TextBox 5">
+            <a:hlinkClick r:id="rId3"/>
+          </p:cNvPr>
+          <p:cNvSpPr txBox="1"/>
+          <p:nvPr/>
+        </p:nvSpPr>
+        <p:spPr>
+          <a:xfrm>
+            <a:off x="2560320" y="6355080"/>
+            <a:ext cx="2011680" cy="320040"/>
+          </a:xfrm>
+          <a:prstGeom prst="rect">
+            <a:avLst/>
+          </a:prstGeom>
+          <a:noFill/>
+        </p:spPr>
+        <p:txBody>
+          <a:bodyPr wrap="none">
+            <a:spAutoFit/>
+          </a:bodyPr>
+          <a:lstStyle/>
+          <a:p>
+            <a:pPr>
+              <a:defRPr sz="1200"/>
+            </a:pPr>
+            <a:r>
+              <a:t>GitHub</a:t>
+            </a:r>
+          </a:p>
+        </p:txBody>
+      </p:sp>
+      <p:sp>
+        <p:nvSpPr>
+          <p:cNvPr id="7" name="TextBox 6">
+            <a:hlinkClick r:id="rId4"/>
+          </p:cNvPr>
+          <p:cNvSpPr txBox="1"/>
+          <p:nvPr/>
+        </p:nvSpPr>
+        <p:spPr>
+          <a:xfrm>
+            <a:off x="4663440" y="6355080"/>
+            <a:ext cx="2011680" cy="320040"/>
+          </a:xfrm>
+          <a:prstGeom prst="rect">
+            <a:avLst/>
+          </a:prstGeom>
+          <a:noFill/>
+        </p:spPr>
+        <p:txBody>
+          <a:bodyPr wrap="none">
+            <a:spAutoFit/>
+          </a:bodyPr>
+          <a:lstStyle/>
+          <a:p>
+            <a:pPr>
+              <a:defRPr sz="1200"/>
+            </a:pPr>
+            <a:r>
+              <a:t>Profile</a:t>
+            </a:r>
+          </a:p>
+        </p:txBody>
+      </p:sp>
+    </p:spTree>
+  </p:cSld>
+  <p:clrMapOvr>
+    <a:masterClrMapping/>
+  </p:clrMapOvr>
+</p:sld>
+</file>
+
+<file path=ppt/slides/slide8.xml><?xml version="1.0" encoding="utf-8"?>
+<p:sld xmlns:a="http://schemas.openxmlformats.org/drawingml/2006/main" xmlns:p="http://schemas.openxmlformats.org/presentationml/2006/main" xmlns:r="http://schemas.openxmlformats.org/officeDocument/2006/relationships">
+  <p:cSld>
+    <p:spTree>
+      <p:nvGrpSpPr>
+        <p:cNvPr id="1" name=""/>
+        <p:cNvGrpSpPr/>
+        <p:nvPr/>
+      </p:nvGrpSpPr>
+      <p:grpSpPr/>
+      <p:sp>
+        <p:nvSpPr>
+          <p:cNvPr id="2" name="TextBox 1"/>
+          <p:cNvSpPr txBox="1"/>
+          <p:nvPr/>
+        </p:nvSpPr>
+        <p:spPr>
+          <a:xfrm>
+            <a:off x="457200" y="274320"/>
+            <a:ext cx="11155680" cy="640080"/>
+          </a:xfrm>
+          <a:prstGeom prst="rect">
+            <a:avLst/>
+          </a:prstGeom>
+          <a:noFill/>
+        </p:spPr>
+        <p:txBody>
+          <a:bodyPr wrap="none">
+            <a:spAutoFit/>
+          </a:bodyPr>
+          <a:lstStyle/>
+          <a:p>
+            <a:pPr>
+              <a:defRPr sz="2800" b="1"/>
+            </a:pPr>
+            <a:r>
+              <a:t>Sources and go deeper</a:t>
+            </a:r>
+          </a:p>
+        </p:txBody>
+      </p:sp>
+      <p:sp>
+        <p:nvSpPr>
+          <p:cNvPr id="3" name="TextBox 2"/>
+          <p:cNvSpPr txBox="1"/>
+          <p:nvPr/>
+        </p:nvSpPr>
+        <p:spPr>
+          <a:xfrm>
+            <a:off x="548640" y="1051560"/>
+            <a:ext cx="10972800" cy="4297680"/>
+          </a:xfrm>
+          <a:prstGeom prst="rect">
+            <a:avLst/>
+          </a:prstGeom>
+          <a:noFill/>
+        </p:spPr>
+        <p:txBody>
+          <a:bodyPr wrap="square">
+            <a:spAutoFit/>
+          </a:bodyPr>
+          <a:lstStyle/>
+          <a:p>
+            <a:pPr>
+              <a:defRPr sz="1400"/>
+            </a:pPr>
+            <a:r>
+              <a:t>IIBA KnowledgeHub, including the BABOK Guide contents (standard). https://www.iiba.org/knowledgehub/ last checked 2026-10.</a:t>
+            </a:r>
+          </a:p>
+          <a:p>
+            <a:pPr>
+              <a:defRPr sz="1400"/>
+            </a:pPr>
+            <a:r>
+              <a:t>BABOK Guide article on the IIBA knowledge hub (standard). confirm. last checked 2026-10.</a:t>
+            </a:r>
+          </a:p>
+          <a:p>
+            <a:pPr>
+              <a:defRPr sz="1400"/>
+            </a:pPr>
+            <a:r>
+              <a:t>IIBA home (official). https://www.iiba.org/ last checked 2026-10.</a:t>
+            </a:r>
+          </a:p>
+          <a:p>
+            <a:pPr>
+              <a:defRPr sz="1400"/>
+            </a:pPr>
+            <a:r>
+              <a:t>Manifesto for Agile Software Development (standard). https://agilemanifesto.org/ last checked 2026-10.</a:t>
+            </a:r>
+          </a:p>
+          <a:p>
+            <a:pPr>
+              <a:defRPr sz="1400"/>
+            </a:pPr>
+            <a:r>
+              <a:t>Principles behind the Agile Manifesto (standard). https://agilemanifesto.org/principles.html last checked 2026-10.</a:t>
+            </a:r>
+          </a:p>
+          <a:p>
+            <a:pPr>
+              <a:defRPr sz="1400"/>
+            </a:pPr>
+            <a:r>
+              <a:t>OMG, about BPMN 2.0 (standard). https://www.omg.org/spec/BPMN/2.0/About-BPMN last checked 2026-10.</a:t>
+            </a:r>
+          </a:p>
+          <a:p>
+            <a:pPr>
+              <a:defRPr sz="1400"/>
+            </a:pPr>
+            <a:r>
+              <a:t>BPMN 2.0 specification PDF (standard). https://www.omg.org/spec/BPMN/2.0/PDF last checked 2026-10.</a:t>
+            </a:r>
+          </a:p>
+        </p:txBody>
+      </p:sp>
+      <p:sp>
+        <p:nvSpPr>
+          <p:cNvPr id="4" name="TextBox 3"/>
+          <p:cNvSpPr txBox="1"/>
+          <p:nvPr/>
+        </p:nvSpPr>
+        <p:spPr>
+          <a:xfrm>
+            <a:off x="457200" y="5623560"/>
+            <a:ext cx="11155680" cy="1005840"/>
+          </a:xfrm>
+          <a:prstGeom prst="rect">
+            <a:avLst/>
+          </a:prstGeom>
+          <a:noFill/>
+        </p:spPr>
+        <p:txBody>
+          <a:bodyPr wrap="square">
+            <a:spAutoFit/>
+          </a:bodyPr>
+          <a:lstStyle/>
+          <a:p>
+            <a:pPr>
+              <a:defRPr sz="1000"/>
+            </a:pPr>
+            <a:r>
+              <a:t>CypherMonkey Labs · © 2026 CypherMonkeyLabs</a:t>
+            </a:r>
+          </a:p>
+          <a:p>
+            <a:r>
+              <a:t>Independent, free, learning-only student project. Respects every company and vendor. Trademarks belong to their owners. Not affiliated or endorsed. Concerns are removed or corrected promptly via the contact form at https</a:t>
+            </a:r>
+          </a:p>
+        </p:txBody>
+      </p:sp>
+      <p:sp>
+        <p:nvSpPr>
+          <p:cNvPr id="5" name="TextBox 4">
+            <a:hlinkClick r:id="rId2"/>
+          </p:cNvPr>
+          <p:cNvSpPr txBox="1"/>
+          <p:nvPr/>
+        </p:nvSpPr>
+        <p:spPr>
+          <a:xfrm>
+            <a:off x="457200" y="6355080"/>
+            <a:ext cx="2011680" cy="320040"/>
+          </a:xfrm>
+          <a:prstGeom prst="rect">
+            <a:avLst/>
+          </a:prstGeom>
+          <a:noFill/>
+        </p:spPr>
+        <p:txBody>
+          <a:bodyPr wrap="none">
+            <a:spAutoFit/>
+          </a:bodyPr>
+          <a:lstStyle/>
+          <a:p>
+            <a:pPr>
+              <a:defRPr sz="1200"/>
+            </a:pPr>
+            <a:r>
+              <a:t>Website</a:t>
+            </a:r>
+          </a:p>
+        </p:txBody>
+      </p:sp>
+      <p:sp>
+        <p:nvSpPr>
+          <p:cNvPr id="6" name="TextBox 5">
+            <a:hlinkClick r:id="rId3"/>
+          </p:cNvPr>
+          <p:cNvSpPr txBox="1"/>
+          <p:nvPr/>
+        </p:nvSpPr>
+        <p:spPr>
+          <a:xfrm>
+            <a:off x="2560320" y="6355080"/>
+            <a:ext cx="2011680" cy="320040"/>
+          </a:xfrm>
+          <a:prstGeom prst="rect">
+            <a:avLst/>
+          </a:prstGeom>
+          <a:noFill/>
+        </p:spPr>
+        <p:txBody>
+          <a:bodyPr wrap="none">
+            <a:spAutoFit/>
+          </a:bodyPr>
+          <a:lstStyle/>
+          <a:p>
+            <a:pPr>
+              <a:defRPr sz="1200"/>
+            </a:pPr>
+            <a:r>
+              <a:t>GitHub</a:t>
+            </a:r>
+          </a:p>
+        </p:txBody>
+      </p:sp>
+      <p:sp>
+        <p:nvSpPr>
+          <p:cNvPr id="7" name="TextBox 6">
+            <a:hlinkClick r:id="rId4"/>
+          </p:cNvPr>
+          <p:cNvSpPr txBox="1"/>
+          <p:nvPr/>
+        </p:nvSpPr>
+        <p:spPr>
+          <a:xfrm>
+            <a:off x="4663440" y="6355080"/>
+            <a:ext cx="2011680" cy="320040"/>
+          </a:xfrm>
+          <a:prstGeom prst="rect">
+            <a:avLst/>
+          </a:prstGeom>
+          <a:noFill/>
+        </p:spPr>
+        <p:txBody>
+          <a:bodyPr wrap="none">
+            <a:spAutoFit/>
+          </a:bodyPr>
+          <a:lstStyle/>
+          <a:p>
+            <a:pPr>
+              <a:defRPr sz="1200"/>
+            </a:pPr>
+            <a:r>
+              <a:t>Profile</a:t>
+            </a:r>
+          </a:p>
+        </p:txBody>
+      </p:sp>
+    </p:spTree>
+  </p:cSld>
+  <p:clrMapOvr>
+    <a:masterClrMapping/>
+  </p:clrMapOvr>
+</p:sld>
+</file>
+
+<file path=ppt/slides/slide9.xml><?xml version="1.0" encoding="utf-8"?>
+<p:sld xmlns:a="http://schemas.openxmlformats.org/drawingml/2006/main" xmlns:p="http://schemas.openxmlformats.org/presentationml/2006/main" xmlns:r="http://schemas.openxmlformats.org/officeDocument/2006/relationships">
+  <p:cSld>
+    <p:spTree>
+      <p:nvGrpSpPr>
+        <p:cNvPr id="1" name=""/>
+        <p:cNvGrpSpPr/>
+        <p:nvPr/>
+      </p:nvGrpSpPr>
+      <p:grpSpPr/>
+      <p:sp>
+        <p:nvSpPr>
+          <p:cNvPr id="2" name="TextBox 1"/>
+          <p:cNvSpPr txBox="1"/>
+          <p:nvPr/>
+        </p:nvSpPr>
+        <p:spPr>
+          <a:xfrm>
+            <a:off x="457200" y="274320"/>
+            <a:ext cx="11155680" cy="640080"/>
+          </a:xfrm>
+          <a:prstGeom prst="rect">
+            <a:avLst/>
+          </a:prstGeom>
+          <a:noFill/>
+        </p:spPr>
+        <p:txBody>
+          <a:bodyPr wrap="none">
+            <a:spAutoFit/>
+          </a:bodyPr>
+          <a:lstStyle/>
+          <a:p>
+            <a:pPr>
+              <a:defRPr sz="2800" b="1"/>
+            </a:pPr>
+            <a:r>
+              <a:t>Sources and go deeper, continued</a:t>
+            </a:r>
+          </a:p>
+        </p:txBody>
+      </p:sp>
+      <p:sp>
+        <p:nvSpPr>
+          <p:cNvPr id="3" name="TextBox 2"/>
+          <p:cNvSpPr txBox="1"/>
+          <p:nvPr/>
+        </p:nvSpPr>
+        <p:spPr>
+          <a:xfrm>
+            <a:off x="548640" y="1051560"/>
+            <a:ext cx="10972800" cy="4297680"/>
+          </a:xfrm>
+          <a:prstGeom prst="rect">
+            <a:avLst/>
+          </a:prstGeom>
+          <a:noFill/>
+        </p:spPr>
+        <p:txBody>
+          <a:bodyPr wrap="square">
+            <a:spAutoFit/>
+          </a:bodyPr>
+          <a:lstStyle/>
+          <a:p>
+            <a:pPr>
+              <a:defRPr sz="1400"/>
+            </a:pPr>
+            <a:r>
+              <a:t>OMG, about BPMN 2.0.2 (standard). https://www.omg.org/spec/BPMN/2.0.2/About-BPMN last checked 2026-10.</a:t>
+            </a:r>
+          </a:p>
+          <a:p>
+            <a:pPr>
+              <a:defRPr sz="1400"/>
+            </a:pPr>
+            <a:r>
+              <a:t>OMG, about UML 2.5.1 (standard). https://www.omg.org/spec/UML/2.5.1/About-UML last checked 2026-10.</a:t>
+            </a:r>
+          </a:p>
+          <a:p>
+            <a:pPr>
+              <a:defRPr sz="1400"/>
+            </a:pPr>
+            <a:r>
+              <a:t>UML 2.5.1 specification PDF (standard). https://www.omg.org/spec/UML/2.5.1/PDF last checked 2026-10.</a:t>
+            </a:r>
+          </a:p>
+          <a:p>
+            <a:pPr>
+              <a:defRPr sz="1400"/>
+            </a:pPr>
+            <a:r>
+              <a:t>IIBA membership (community). https://www.iiba.org/membership/ last checked 2026-10.</a:t>
+            </a:r>
+          </a:p>
+          <a:p>
+            <a:pPr>
+              <a:defRPr sz="1400"/>
+            </a:pPr>
+            <a:r>
+              <a:t>OMG managed communities (community). https://www.omg.org/communities/ last checked 2026-10.</a:t>
+            </a:r>
+          </a:p>
+          <a:p>
+            <a:pPr>
+              <a:defRPr sz="1400"/>
+            </a:pPr>
+            <a:r>
+              <a:t>About IIBA (official). https://www.iiba.org/about-iiba/ last checked 2026-10.</a:t>
+            </a:r>
+          </a:p>
+          <a:p>
+            <a:pPr>
+              <a:defRPr sz="1400"/>
+            </a:pPr>
+            <a:r>
+              <a:t>WCAG 2.2 recommendation (standard). https://www.w3.org/TR/WCAG22/ last checked 2026-10.</a:t>
             </a:r>
           </a:p>
         </p:txBody>

</xml_diff>

<commit_message>
Add contact-center journey, metric, and migration rooms.
The Learn menu now opens omnichannel journeys, contact-center metrics, and cloud-migration artifacts, and the ecosystem room adds a glossary, mind map, sister technologies, and integration sequence. Formulas and artifacts are taken from pages opened in October 2026. The catalog now counts 169 notes, 75 diagrams, 36 flows, and 54 cards.

Co-authored-by: CYPHER0X9 <cipher0x9@users.noreply.github.com>
</commit_message>
<xml_diff>
--- a/downloads/ba-study-deck.pptx
+++ b/downloads/ba-study-deck.pptx
@@ -3206,7 +3206,7 @@
           </a:p>
           <a:p>
             <a:r>
-              <a:t>Independent, free, learning-only student project. Respects every company and vendor. Trademarks belong to their owners. Not affiliated or endorsed. Concerns are removed or corrected promptly via the contact form at https</a:t>
+              <a:t>Independent, free, learning-only student project. Respects every company and vendor. Trademarks belong to their owners. Not affiliated or endorsed. Names in the contact-center rooms are citations of pages opened in Octob</a:t>
             </a:r>
           </a:p>
         </p:txBody>
@@ -3388,6 +3388,30 @@
               <a:t>How to Meet WCAG, quick reference (official). https://www.w3.org/WAI/WCAG22/quickref/ last checked 2026-10.</a:t>
             </a:r>
           </a:p>
+          <a:p>
+            <a:pPr>
+              <a:defRPr sz="1400"/>
+            </a:pPr>
+            <a:r>
+              <a:t>Connect Customer feature overview (official). https://docs.aws.amazon.com/connect/latest/adminguide/connect-feature-overview.html last checked 2026-10.</a:t>
+            </a:r>
+          </a:p>
+          <a:p>
+            <a:pPr>
+              <a:defRPr sz="1400"/>
+            </a:pPr>
+            <a:r>
+              <a:t>Connect Customer metric definitions (official). https://docs.aws.amazon.com/connect/latest/adminguide/metrics-definitions.html last checked 2026-10.</a:t>
+            </a:r>
+          </a:p>
+          <a:p>
+            <a:pPr>
+              <a:defRPr sz="1400"/>
+            </a:pPr>
+            <a:r>
+              <a:t>AWS Prescriptive Guidance, project phases and workstreams (official). https://docs.aws.amazon.com/prescriptive-guidance/latest/strategy-migration-connect/workstreams.html last checked 2026-10.</a:t>
+            </a:r>
+          </a:p>
         </p:txBody>
       </p:sp>
       <p:sp>
@@ -3421,7 +3445,7 @@
           </a:p>
           <a:p>
             <a:r>
-              <a:t>Independent, free, learning-only student project. Respects every company and vendor. Trademarks belong to their owners. Not affiliated or endorsed. Concerns are removed or corrected promptly via the contact form at https</a:t>
+              <a:t>Independent, free, learning-only student project. Respects every company and vendor. Trademarks belong to their owners. Not affiliated or endorsed. Names in the contact-center rooms are citations of pages opened in Octob</a:t>
             </a:r>
           </a:p>
         </p:txBody>
@@ -3652,7 +3676,7 @@
           </a:p>
           <a:p>
             <a:r>
-              <a:t>Independent, free, learning-only student project. Respects every company and vendor. Trademarks belong to their owners. Not affiliated or endorsed. Concerns are removed or corrected promptly via the contact form at https</a:t>
+              <a:t>Independent, free, learning-only student project. Respects every company and vendor. Trademarks belong to their owners. Not affiliated or endorsed. Names in the contact-center rooms are citations of pages opened in Octob</a:t>
             </a:r>
           </a:p>
         </p:txBody>
@@ -3891,7 +3915,7 @@
           </a:p>
           <a:p>
             <a:r>
-              <a:t>Independent, free, learning-only student project. Respects every company and vendor. Trademarks belong to their owners. Not affiliated or endorsed. Concerns are removed or corrected promptly via the contact form at https</a:t>
+              <a:t>Independent, free, learning-only student project. Respects every company and vendor. Trademarks belong to their owners. Not affiliated or endorsed. Names in the contact-center rooms are citations of pages opened in Octob</a:t>
             </a:r>
           </a:p>
         </p:txBody>
@@ -4122,7 +4146,7 @@
           </a:p>
           <a:p>
             <a:r>
-              <a:t>Independent, free, learning-only student project. Respects every company and vendor. Trademarks belong to their owners. Not affiliated or endorsed. Concerns are removed or corrected promptly via the contact form at https</a:t>
+              <a:t>Independent, free, learning-only student project. Respects every company and vendor. Trademarks belong to their owners. Not affiliated or endorsed. Names in the contact-center rooms are citations of pages opened in Octob</a:t>
             </a:r>
           </a:p>
         </p:txBody>
@@ -4353,7 +4377,7 @@
           </a:p>
           <a:p>
             <a:r>
-              <a:t>Independent, free, learning-only student project. Respects every company and vendor. Trademarks belong to their owners. Not affiliated or endorsed. Concerns are removed or corrected promptly via the contact form at https</a:t>
+              <a:t>Independent, free, learning-only student project. Respects every company and vendor. Trademarks belong to their owners. Not affiliated or endorsed. Names in the contact-center rooms are citations of pages opened in Octob</a:t>
             </a:r>
           </a:p>
         </p:txBody>
@@ -4584,7 +4608,7 @@
           </a:p>
           <a:p>
             <a:r>
-              <a:t>Independent, free, learning-only student project. Respects every company and vendor. Trademarks belong to their owners. Not affiliated or endorsed. Concerns are removed or corrected promptly via the contact form at https</a:t>
+              <a:t>Independent, free, learning-only student project. Respects every company and vendor. Trademarks belong to their owners. Not affiliated or endorsed. Names in the contact-center rooms are citations of pages opened in Octob</a:t>
             </a:r>
           </a:p>
         </p:txBody>
@@ -4815,7 +4839,7 @@
           </a:p>
           <a:p>
             <a:r>
-              <a:t>Independent, free, learning-only student project. Respects every company and vendor. Trademarks belong to their owners. Not affiliated or endorsed. Concerns are removed or corrected promptly via the contact form at https</a:t>
+              <a:t>Independent, free, learning-only student project. Respects every company and vendor. Trademarks belong to their owners. Not affiliated or endorsed. Names in the contact-center rooms are citations of pages opened in Octob</a:t>
             </a:r>
           </a:p>
         </p:txBody>
@@ -5078,7 +5102,7 @@
           </a:p>
           <a:p>
             <a:r>
-              <a:t>Independent, free, learning-only student project. Respects every company and vendor. Trademarks belong to their owners. Not affiliated or endorsed. Concerns are removed or corrected promptly via the contact form at https</a:t>
+              <a:t>Independent, free, learning-only student project. Respects every company and vendor. Trademarks belong to their owners. Not affiliated or endorsed. Names in the contact-center rooms are citations of pages opened in Octob</a:t>
             </a:r>
           </a:p>
         </p:txBody>
@@ -5341,7 +5365,7 @@
           </a:p>
           <a:p>
             <a:r>
-              <a:t>Independent, free, learning-only student project. Respects every company and vendor. Trademarks belong to their owners. Not affiliated or endorsed. Concerns are removed or corrected promptly via the contact form at https</a:t>
+              <a:t>Independent, free, learning-only student project. Respects every company and vendor. Trademarks belong to their owners. Not affiliated or endorsed. Names in the contact-center rooms are citations of pages opened in Octob</a:t>
             </a:r>
           </a:p>
         </p:txBody>

</xml_diff>

<commit_message>
Add contact-center journey, metric, and migration rooms. (#4)
The Learn menu now opens omnichannel journeys, contact-center metrics, and cloud-migration artifacts, and the ecosystem room adds a glossary, mind map, sister technologies, and integration sequence. Formulas and artifacts are taken from pages opened in October 2026. The catalog now counts 169 notes, 75 diagrams, 36 flows, and 54 cards.

Co-authored-by: Cursor Agent <cursoragent@cursor.com>
Co-authored-by: CYPHER0X9 <cipher0x9@users.noreply.github.com>
</commit_message>
<xml_diff>
--- a/downloads/ba-study-deck.pptx
+++ b/downloads/ba-study-deck.pptx
@@ -3206,7 +3206,7 @@
           </a:p>
           <a:p>
             <a:r>
-              <a:t>Independent, free, learning-only student project. Respects every company and vendor. Trademarks belong to their owners. Not affiliated or endorsed. Concerns are removed or corrected promptly via the contact form at https</a:t>
+              <a:t>Independent, free, learning-only student project. Respects every company and vendor. Trademarks belong to their owners. Not affiliated or endorsed. Names in the contact-center rooms are citations of pages opened in Octob</a:t>
             </a:r>
           </a:p>
         </p:txBody>
@@ -3388,6 +3388,30 @@
               <a:t>How to Meet WCAG, quick reference (official). https://www.w3.org/WAI/WCAG22/quickref/ last checked 2026-10.</a:t>
             </a:r>
           </a:p>
+          <a:p>
+            <a:pPr>
+              <a:defRPr sz="1400"/>
+            </a:pPr>
+            <a:r>
+              <a:t>Connect Customer feature overview (official). https://docs.aws.amazon.com/connect/latest/adminguide/connect-feature-overview.html last checked 2026-10.</a:t>
+            </a:r>
+          </a:p>
+          <a:p>
+            <a:pPr>
+              <a:defRPr sz="1400"/>
+            </a:pPr>
+            <a:r>
+              <a:t>Connect Customer metric definitions (official). https://docs.aws.amazon.com/connect/latest/adminguide/metrics-definitions.html last checked 2026-10.</a:t>
+            </a:r>
+          </a:p>
+          <a:p>
+            <a:pPr>
+              <a:defRPr sz="1400"/>
+            </a:pPr>
+            <a:r>
+              <a:t>AWS Prescriptive Guidance, project phases and workstreams (official). https://docs.aws.amazon.com/prescriptive-guidance/latest/strategy-migration-connect/workstreams.html last checked 2026-10.</a:t>
+            </a:r>
+          </a:p>
         </p:txBody>
       </p:sp>
       <p:sp>
@@ -3421,7 +3445,7 @@
           </a:p>
           <a:p>
             <a:r>
-              <a:t>Independent, free, learning-only student project. Respects every company and vendor. Trademarks belong to their owners. Not affiliated or endorsed. Concerns are removed or corrected promptly via the contact form at https</a:t>
+              <a:t>Independent, free, learning-only student project. Respects every company and vendor. Trademarks belong to their owners. Not affiliated or endorsed. Names in the contact-center rooms are citations of pages opened in Octob</a:t>
             </a:r>
           </a:p>
         </p:txBody>
@@ -3652,7 +3676,7 @@
           </a:p>
           <a:p>
             <a:r>
-              <a:t>Independent, free, learning-only student project. Respects every company and vendor. Trademarks belong to their owners. Not affiliated or endorsed. Concerns are removed or corrected promptly via the contact form at https</a:t>
+              <a:t>Independent, free, learning-only student project. Respects every company and vendor. Trademarks belong to their owners. Not affiliated or endorsed. Names in the contact-center rooms are citations of pages opened in Octob</a:t>
             </a:r>
           </a:p>
         </p:txBody>
@@ -3891,7 +3915,7 @@
           </a:p>
           <a:p>
             <a:r>
-              <a:t>Independent, free, learning-only student project. Respects every company and vendor. Trademarks belong to their owners. Not affiliated or endorsed. Concerns are removed or corrected promptly via the contact form at https</a:t>
+              <a:t>Independent, free, learning-only student project. Respects every company and vendor. Trademarks belong to their owners. Not affiliated or endorsed. Names in the contact-center rooms are citations of pages opened in Octob</a:t>
             </a:r>
           </a:p>
         </p:txBody>
@@ -4122,7 +4146,7 @@
           </a:p>
           <a:p>
             <a:r>
-              <a:t>Independent, free, learning-only student project. Respects every company and vendor. Trademarks belong to their owners. Not affiliated or endorsed. Concerns are removed or corrected promptly via the contact form at https</a:t>
+              <a:t>Independent, free, learning-only student project. Respects every company and vendor. Trademarks belong to their owners. Not affiliated or endorsed. Names in the contact-center rooms are citations of pages opened in Octob</a:t>
             </a:r>
           </a:p>
         </p:txBody>
@@ -4353,7 +4377,7 @@
           </a:p>
           <a:p>
             <a:r>
-              <a:t>Independent, free, learning-only student project. Respects every company and vendor. Trademarks belong to their owners. Not affiliated or endorsed. Concerns are removed or corrected promptly via the contact form at https</a:t>
+              <a:t>Independent, free, learning-only student project. Respects every company and vendor. Trademarks belong to their owners. Not affiliated or endorsed. Names in the contact-center rooms are citations of pages opened in Octob</a:t>
             </a:r>
           </a:p>
         </p:txBody>
@@ -4584,7 +4608,7 @@
           </a:p>
           <a:p>
             <a:r>
-              <a:t>Independent, free, learning-only student project. Respects every company and vendor. Trademarks belong to their owners. Not affiliated or endorsed. Concerns are removed or corrected promptly via the contact form at https</a:t>
+              <a:t>Independent, free, learning-only student project. Respects every company and vendor. Trademarks belong to their owners. Not affiliated or endorsed. Names in the contact-center rooms are citations of pages opened in Octob</a:t>
             </a:r>
           </a:p>
         </p:txBody>
@@ -4815,7 +4839,7 @@
           </a:p>
           <a:p>
             <a:r>
-              <a:t>Independent, free, learning-only student project. Respects every company and vendor. Trademarks belong to their owners. Not affiliated or endorsed. Concerns are removed or corrected promptly via the contact form at https</a:t>
+              <a:t>Independent, free, learning-only student project. Respects every company and vendor. Trademarks belong to their owners. Not affiliated or endorsed. Names in the contact-center rooms are citations of pages opened in Octob</a:t>
             </a:r>
           </a:p>
         </p:txBody>
@@ -5078,7 +5102,7 @@
           </a:p>
           <a:p>
             <a:r>
-              <a:t>Independent, free, learning-only student project. Respects every company and vendor. Trademarks belong to their owners. Not affiliated or endorsed. Concerns are removed or corrected promptly via the contact form at https</a:t>
+              <a:t>Independent, free, learning-only student project. Respects every company and vendor. Trademarks belong to their owners. Not affiliated or endorsed. Names in the contact-center rooms are citations of pages opened in Octob</a:t>
             </a:r>
           </a:p>
         </p:txBody>
@@ -5341,7 +5365,7 @@
           </a:p>
           <a:p>
             <a:r>
-              <a:t>Independent, free, learning-only student project. Respects every company and vendor. Trademarks belong to their owners. Not affiliated or endorsed. Concerns are removed or corrected promptly via the contact form at https</a:t>
+              <a:t>Independent, free, learning-only student project. Respects every company and vendor. Trademarks belong to their owners. Not affiliated or endorsed. Names in the contact-center rooms are citations of pages opened in Octob</a:t>
             </a:r>
           </a:p>
         </p:txBody>

</xml_diff>